<commit_message>
Present combined-data retrain: date-balanced holdout and process deck
Ship the 10-slide update PPT and docs against the 172,343-row combined
logreg (golden + hourly + Jan–Apr minutes + 111 visual overrides).
</commit_message>
<xml_diff>
--- a/KFB_Process_Update.pptx
+++ b/KFB_Process_Update.pptx
@@ -3166,14 +3166,14 @@
               </a:spcAft>
             </a:pPr>
             <a:r>
-              <a:rPr sz="2200" b="0">
+              <a:rPr sz="2000" b="0">
                 <a:solidFill>
                   <a:srgbClr val="A9D3EE"/>
                 </a:solidFill>
                 <a:latin typeface="Helvetica Neue"/>
                 <a:ea typeface="PingFang TC"/>
               </a:rPr>
-              <a:t>Process update — combine data, holdout, ship</a:t>
+              <a:t>Process update — combine every unique label, hold out dates, ship</a:t>
             </a:r>
           </a:p>
           <a:p>
@@ -3190,7 +3190,7 @@
                 <a:latin typeface="Helvetica Neue"/>
                 <a:ea typeface="PingFang TC"/>
               </a:rPr>
-              <a:t>8,354 unique frames  ·  date-grouped 80/20  ·  111 visual GT</a:t>
+              <a:t>172,343 unique frames  ·  357 dates  ·  date-balanced 80/20</a:t>
             </a:r>
           </a:p>
           <a:p>
@@ -3207,7 +3207,7 @@
                 <a:latin typeface="Helvetica Neue"/>
                 <a:ea typeface="PingFang TC"/>
               </a:rPr>
-              <a:t>Test 96.2%  ·  golden 97.2%  ·  111 86.5%  ·  day 98.2%  ·  night 75.0%</a:t>
+              <a:t>Holdout 97.8%  ·  golden 96.5%  ·  111 86.5%  ·  day 96.4%  ·  night 76.8%</a:t>
             </a:r>
           </a:p>
         </p:txBody>
@@ -3554,7 +3554,7 @@
                 <a:latin typeface="Helvetica Neue"/>
                 <a:ea typeface="PingFang TC"/>
               </a:rPr>
-              <a:t>Fit pool</a:t>
+              <a:t>Train rows</a:t>
             </a:r>
           </a:p>
           <a:p>
@@ -3571,7 +3571,7 @@
                 <a:latin typeface="Helvetica Neue"/>
                 <a:ea typeface="PingFang TC"/>
               </a:rPr>
-              <a:t>8,354 rows</a:t>
+              <a:t>172,343</a:t>
             </a:r>
           </a:p>
           <a:p>
@@ -3588,7 +3588,7 @@
                 <a:latin typeface="Helvetica Neue"/>
                 <a:ea typeface="PingFang TC"/>
               </a:rPr>
-              <a:t>142 + 8,101 + 111. 166k minutes extracted, not shipped.</a:t>
+              <a:t>Unique frames. Human overrides heuristic. Date-balanced.</a:t>
             </a:r>
           </a:p>
         </p:txBody>
@@ -3674,7 +3674,7 @@
                 <a:latin typeface="Helvetica Neue"/>
                 <a:ea typeface="PingFang TC"/>
               </a:rPr>
-              <a:t>Day</a:t>
+              <a:t>Holdout</a:t>
             </a:r>
           </a:p>
           <a:p>
@@ -3691,7 +3691,7 @@
                 <a:latin typeface="Helvetica Neue"/>
                 <a:ea typeface="PingFang TC"/>
               </a:rPr>
-              <a:t>98.2%</a:t>
+              <a:t>97.8%</a:t>
             </a:r>
           </a:p>
           <a:p>
@@ -3708,7 +3708,7 @@
                 <a:latin typeface="Helvetica Neue"/>
                 <a:ea typeface="PingFang TC"/>
               </a:rPr>
-              <a:t>Strong on the 111 visual frames. Brief as ready.</a:t>
+              <a:t>42,714 unseen-date rows. Tied with d413d74.</a:t>
             </a:r>
           </a:p>
         </p:txBody>
@@ -3794,7 +3794,7 @@
                 <a:latin typeface="Helvetica Neue"/>
                 <a:ea typeface="PingFang TC"/>
               </a:rPr>
-              <a:t>Night</a:t>
+              <a:t>111 visual</a:t>
             </a:r>
           </a:p>
           <a:p>
@@ -3811,7 +3811,7 @@
                 <a:latin typeface="Helvetica Neue"/>
                 <a:ea typeface="PingFang TC"/>
               </a:rPr>
-              <a:t>75.0%</a:t>
+              <a:t>86.5%</a:t>
             </a:r>
           </a:p>
           <a:p>
@@ -3828,7 +3828,7 @@
                 <a:latin typeface="Helvetica Neue"/>
                 <a:ea typeface="PingFang TC"/>
               </a:rPr>
-              <a:t>High recall, too many faint-light false alarms. Next golden set.</a:t>
+              <a:t>Day 96.4% · night 76.8%.</a:t>
             </a:r>
           </a:p>
         </p:txBody>
@@ -3931,7 +3931,7 @@
                 <a:latin typeface="Helvetica Neue"/>
                 <a:ea typeface="PingFang TC"/>
               </a:rPr>
-              <a:t>We combined 2016 human labels, a full year of 2023 hourly frames, and 111 visual overrides; evaluated on dates the fit never saw; and refused 166k extra minutes that hurt those checks. Daytime inside-cloud is the win. Night labeling is the next process.</a:t>
+              <a:t>Every unique labeled KFB frame is now in the model, weighted so a January minute does not count more than a November hour, and so 253 human rows still speak. Unseen dates score 97.8% against seed labels and 86.5% against visual photos. Night labeling is still the next process.</a:t>
             </a:r>
           </a:p>
         </p:txBody>
@@ -4169,7 +4169,7 @@
                 <a:latin typeface="Helvetica Neue"/>
                 <a:ea typeface="PingFang TC"/>
               </a:rPr>
-              <a:t>Combine useful labels, keep a date holdout, refuse volume that hurts honesty.</a:t>
+              <a:t>v1 used 2016. d413d74 added 2023 hourly. This ships every unique frame.</a:t>
             </a:r>
           </a:p>
         </p:txBody>
@@ -4272,7 +4272,7 @@
                 <a:latin typeface="Helvetica Neue"/>
                 <a:ea typeface="PingFang TC"/>
               </a:rPr>
-              <a:t>•  142 golden 2016 + 8,212 hourly 2023</a:t>
+              <a:t>•  8,354 rows: 142 golden + 8,212 hourly</a:t>
             </a:r>
           </a:p>
           <a:p>
@@ -4289,6 +4289,23 @@
                 <a:latin typeface="Helvetica Neue"/>
                 <a:ea typeface="PingFang TC"/>
               </a:rPr>
+              <a:t>•  No Jan–Apr minutes in the fit</a:t>
+            </a:r>
+          </a:p>
+          <a:p>
+            <a:pPr>
+              <a:spcAft>
+                <a:spcPts val="800"/>
+              </a:spcAft>
+            </a:pPr>
+            <a:r>
+              <a:rPr sz="1400" b="0">
+                <a:solidFill>
+                  <a:srgbClr val="22303C"/>
+                </a:solidFill>
+                <a:latin typeface="Helvetica Neue"/>
+                <a:ea typeface="PingFang TC"/>
+              </a:rPr>
               <a:t>•  Date-grouped 80/20, train-split fit</a:t>
             </a:r>
           </a:p>
@@ -4306,7 +4323,7 @@
                 <a:latin typeface="Helvetica Neue"/>
                 <a:ea typeface="PingFang TC"/>
               </a:rPr>
-              <a:t>•  Test 97.2% (mostly heuristic labels)</a:t>
+              <a:t>•  111 visual check 83.8% / day 94.6%</a:t>
             </a:r>
           </a:p>
           <a:p>
@@ -4323,24 +4340,7 @@
                 <a:latin typeface="Helvetica Neue"/>
                 <a:ea typeface="PingFang TC"/>
               </a:rPr>
-              <a:t>•  111 visual check 83.8% / day 94.6%</a:t>
-            </a:r>
-          </a:p>
-          <a:p>
-            <a:pPr>
-              <a:spcAft>
-                <a:spcPts val="800"/>
-              </a:spcAft>
-            </a:pPr>
-            <a:r>
-              <a:rPr sz="1400" b="0">
-                <a:solidFill>
-                  <a:srgbClr val="22303C"/>
-                </a:solidFill>
-                <a:latin typeface="Helvetica Neue"/>
-                <a:ea typeface="PingFang TC"/>
-              </a:rPr>
-              <a:t>•  Night 73.2% still the weak spot</a:t>
+              <a:t>•  Night 73.2% still the weak slice</a:t>
             </a:r>
           </a:p>
         </p:txBody>
@@ -4426,7 +4426,7 @@
                 <a:latin typeface="Helvetica Neue"/>
                 <a:ea typeface="PingFang TC"/>
               </a:rPr>
-              <a:t>What we added</a:t>
+              <a:t>What changed</a:t>
             </a:r>
           </a:p>
           <a:p>
@@ -4443,7 +4443,7 @@
                 <a:latin typeface="Helvetica Neue"/>
                 <a:ea typeface="PingFang TC"/>
               </a:rPr>
-              <a:t>•  Finished Jan-Apr per-minute extract: 166,772</a:t>
+              <a:t>•  Add 163,989 extra per-minute rows</a:t>
             </a:r>
           </a:p>
           <a:p>
@@ -4460,7 +4460,7 @@
                 <a:latin typeface="Helvetica Neue"/>
                 <a:ea typeface="PingFang TC"/>
               </a:rPr>
-              <a:t>•  Tried shipping those minutes — they lost</a:t>
+              <a:t>•  111 visual labels override hourly seed</a:t>
             </a:r>
           </a:p>
           <a:p>
@@ -4477,7 +4477,7 @@
                 <a:latin typeface="Helvetica Neue"/>
                 <a:ea typeface="PingFang TC"/>
               </a:rPr>
-              <a:t>•  111 visual labels as human overrides</a:t>
+              <a:t>•  Weight 1/date, humans ×20</a:t>
             </a:r>
           </a:p>
           <a:p>
@@ -4494,7 +4494,7 @@
                 <a:latin typeface="Helvetica Neue"/>
                 <a:ea typeface="PingFang TC"/>
               </a:rPr>
-              <a:t>•  Human rows weighted x20 vs hourly seed</a:t>
+              <a:t>•  Date-grouped 80/20, train-split fit</a:t>
             </a:r>
           </a:p>
           <a:p>
@@ -4511,7 +4511,7 @@
                 <a:latin typeface="Helvetica Neue"/>
                 <a:ea typeface="PingFang TC"/>
               </a:rPr>
-              <a:t>•  Same tiny JSON in Python and the browser</a:t>
+              <a:t>•  Same 9 features, same JSON export</a:t>
             </a:r>
           </a:p>
         </p:txBody>
@@ -4597,7 +4597,7 @@
                 <a:latin typeface="Helvetica Neue"/>
                 <a:ea typeface="PingFang TC"/>
               </a:rPr>
-              <a:t>Why it matters</a:t>
+              <a:t>Why date-balance</a:t>
             </a:r>
           </a:p>
           <a:p>
@@ -4614,7 +4614,7 @@
                 <a:latin typeface="Helvetica Neue"/>
                 <a:ea typeface="PingFang TC"/>
               </a:rPr>
-              <a:t>•  Golden-all 97.2% vs previous 95.1%</a:t>
+              <a:t>•  Jan–Apr is ~1,440 frames/day</a:t>
             </a:r>
           </a:p>
           <a:p>
@@ -4631,7 +4631,7 @@
                 <a:latin typeface="Helvetica Neue"/>
                 <a:ea typeface="PingFang TC"/>
               </a:rPr>
-              <a:t>•  111-photo 86.5% vs 83.8% vs rules 73.0%</a:t>
+              <a:t>•  May–Dec is only 24 hourly frames/day</a:t>
             </a:r>
           </a:p>
           <a:p>
@@ -4648,7 +4648,7 @@
                 <a:latin typeface="Helvetica Neue"/>
                 <a:ea typeface="PingFang TC"/>
               </a:rPr>
-              <a:t>•  Day 98.2% is the operational win</a:t>
+              <a:t>•  Equal-weight minutes drown later months</a:t>
             </a:r>
           </a:p>
           <a:p>
@@ -4665,7 +4665,7 @@
                 <a:latin typeface="Helvetica Neue"/>
                 <a:ea typeface="PingFang TC"/>
               </a:rPr>
-              <a:t>•  166k extra minutes were not progress</a:t>
+              <a:t>•  Mass: golden 40%, hourly 35%, minutes 18%, 111 7%</a:t>
             </a:r>
           </a:p>
           <a:p>
@@ -4682,7 +4682,7 @@
                 <a:latin typeface="Helvetica Neue"/>
                 <a:ea typeface="PingFang TC"/>
               </a:rPr>
-              <a:t>•  Night labeling is still the next process</a:t>
+              <a:t>•  Keeps a full-year prior in the model</a:t>
             </a:r>
           </a:p>
         </p:txBody>
@@ -4880,7 +4880,7 @@
                 <a:latin typeface="Helvetica Neue"/>
                 <a:ea typeface="PingFang TC"/>
               </a:rPr>
-              <a:t>Photos -&gt; 9 features -&gt; heuristic seed -&gt; human override -&gt; date-split train -&gt; live</a:t>
+              <a:t>Photos → features → seed labels → human override → date-split train → live</a:t>
             </a:r>
           </a:p>
         </p:txBody>
@@ -4955,7 +4955,7 @@
                 <a:latin typeface="Helvetica Neue"/>
                 <a:ea typeface="PingFang TC"/>
               </a:rPr>
-              <a:t>R5 USB 2023 + 2016 golden</a:t>
+              <a:t>Hourly year + Jan–Apr minutes</a:t>
             </a:r>
           </a:p>
         </p:txBody>
@@ -5180,7 +5180,7 @@
                 <a:latin typeface="Helvetica Neue"/>
                 <a:ea typeface="PingFang TC"/>
               </a:rPr>
-              <a:t>142 + 111 visual override</a:t>
+              <a:t>142 golden + 111 visual</a:t>
             </a:r>
           </a:p>
         </p:txBody>
@@ -5255,7 +5255,7 @@
                 <a:latin typeface="Helvetica Neue"/>
                 <a:ea typeface="PingFang TC"/>
               </a:rPr>
-              <a:t>logreg, split by date</a:t>
+              <a:t>date-balanced 80/20</a:t>
             </a:r>
           </a:p>
         </p:txBody>
@@ -5502,7 +5502,7 @@
                 <a:latin typeface="Helvetica Neue"/>
                 <a:ea typeface="PingFang TC"/>
               </a:rPr>
-              <a:t>Features</a:t>
+              <a:t>Dedup</a:t>
             </a:r>
             <a:r>
               <a:rPr sz="1300" b="0">
@@ -5512,7 +5512,7 @@
                 <a:latin typeface="Helvetica Neue"/>
                 <a:ea typeface="PingFang TC"/>
               </a:rPr>
-              <a:t>   brightness, saturation, far-field wash/grad/std, bright-spot ratio, day/night from brightness &gt;= 80.</a:t>
+              <a:t>   Filename unique. Hourly overwrites the matching minute. Golden and 111 override both.</a:t>
             </a:r>
           </a:p>
         </p:txBody>
@@ -5593,7 +5593,7 @@
                 <a:latin typeface="Helvetica Neue"/>
                 <a:ea typeface="PingFang TC"/>
               </a:rPr>
-              <a:t>Seed vs truth</a:t>
+              <a:t>Weights</a:t>
             </a:r>
             <a:r>
               <a:rPr sz="1300" b="0">
@@ -5603,7 +5603,7 @@
                 <a:latin typeface="Helvetica Neue"/>
                 <a:ea typeface="PingFang TC"/>
               </a:rPr>
-              <a:t>   Hourly heuristic trains volume. Human eye overrides 142 + 111 rows. The model never labels itself.</a:t>
+              <a:t>   (1 / n_frames on that YYMMDD) × 20 if human. Mean-normalized so April minutes cannot own the loss.</a:t>
             </a:r>
           </a:p>
         </p:txBody>
@@ -5694,7 +5694,7 @@
                 <a:latin typeface="Helvetica Neue"/>
                 <a:ea typeface="PingFang TC"/>
               </a:rPr>
-              <a:t>   GroupShuffleSplit by YYMMDD, random_state=42. Weights fit on train only — no full-data refit.</a:t>
+              <a:t>   GroupShuffleSplit by date, rs=42. Shipped JSON is the train-split fit — no full-data refit.</a:t>
             </a:r>
           </a:p>
         </p:txBody>
@@ -5785,7 +5785,7 @@
                 <a:latin typeface="Helvetica Neue"/>
                 <a:ea typeface="PingFang TC"/>
               </a:rPr>
-              <a:t>   GitHub Actions every ~5 min -&gt; live.json. Pages runs the same JSON if the feed is stale.</a:t>
+              <a:t>   GitHub Actions every ~5 min → live.json. Pages runs the same JSON if the feed is stale.</a:t>
             </a:r>
           </a:p>
         </p:txBody>
@@ -5966,7 +5966,7 @@
                 <a:latin typeface="Helvetica Neue"/>
                 <a:ea typeface="PingFang TC"/>
               </a:rPr>
-              <a:t>What was combined — and what was not</a:t>
+              <a:t>All train data combined</a:t>
             </a:r>
           </a:p>
           <a:p>
@@ -5983,7 +5983,7 @@
                 <a:latin typeface="Helvetica Neue"/>
                 <a:ea typeface="PingFang TC"/>
               </a:rPr>
-              <a:t>8,354 unique frames · 704 inside · 357 dates</a:t>
+              <a:t>172,343 unique frames · 21,583 inside_cloud · 357 dates</a:t>
             </a:r>
           </a:p>
         </p:txBody>
@@ -6110,7 +6110,7 @@
                 <a:latin typeface="Helvetica Neue"/>
                 <a:ea typeface="PingFang TC"/>
               </a:rPr>
-              <a:t>•  Golden 142 (2016) — human. 34 inside. Weighted x20.</a:t>
+              <a:t>•  Golden 142 (2016, human) — honest labels. Override any auto-label.</a:t>
             </a:r>
           </a:p>
           <a:p>
@@ -6127,7 +6127,7 @@
                 <a:latin typeface="Helvetica Neue"/>
                 <a:ea typeface="PingFang TC"/>
               </a:rPr>
-              <a:t>•  R5 hourly 8,212 (2023, full year) — heuristic seed. 111 overridden by visual GT.</a:t>
+              <a:t>•  R5 hourly 8,101 (2023) — year-round seed. How May–Dec enter the model.</a:t>
             </a:r>
           </a:p>
           <a:p>
@@ -6144,7 +6144,7 @@
                 <a:latin typeface="Helvetica Neue"/>
                 <a:ea typeface="PingFang TC"/>
               </a:rPr>
-              <a:t>•  Review 111 — visual GT, join the date split. 20 fall on test dates.</a:t>
+              <a:t>•  R5 extra minutes 163,989 (Jan–Apr) — denser time, down-weighted per date.</a:t>
             </a:r>
           </a:p>
           <a:p>
@@ -6161,7 +6161,7 @@
                 <a:latin typeface="Helvetica Neue"/>
                 <a:ea typeface="PingFang TC"/>
               </a:rPr>
-              <a:t>•  Per-minute 166,772 — extract finished Jan-Apr 22. Tried; honest checks fell. Not shipped.</a:t>
+              <a:t>•  Review 111 — visual GT overrides. 20 on test dates.</a:t>
             </a:r>
           </a:p>
           <a:p>
@@ -6178,7 +6178,7 @@
                 <a:latin typeface="Helvetica Neue"/>
                 <a:ea typeface="PingFang TC"/>
               </a:rPr>
-              <a:t>Shipped = 8,354 unique rows, 80/20 by date, train-split fit.</a:t>
+              <a:t>USB minutes stop 22 Apr. Date-balance is how we still keep a year.</a:t>
             </a:r>
           </a:p>
         </p:txBody>
@@ -6376,7 +6376,7 @@
                 <a:latin typeface="Helvetica Neue"/>
                 <a:ea typeface="PingFang TC"/>
               </a:rPr>
-              <a:t>review_r5/grid_01-13.jpg — judged against the project rule, then used as human overrides</a:t>
+              <a:t>review_r5/grid_01–13.jpg — judged against the project rule, then used as human overrides</a:t>
             </a:r>
           </a:p>
         </p:txBody>
@@ -6735,7 +6735,7 @@
                 <a:latin typeface="Helvetica Neue"/>
                 <a:ea typeface="PingFang TC"/>
               </a:rPr>
-              <a:t>Day: washed-out textureless far field = inside; visible valley = not inside.  Night: lightless flat frame = inside; any valley lights = not inside.  Haze with a visible valley is not inside. Result: 57 inside / 54 not inside.</a:t>
+              <a:t>Day: washed-out textureless far field = inside; visible valley = not inside.  Night: lightless flat frame = inside; any valley lights = not inside.  Result: 57 inside / 54 not inside.</a:t>
             </a:r>
           </a:p>
         </p:txBody>
@@ -6916,7 +6916,7 @@
                 <a:latin typeface="Helvetica Neue"/>
                 <a:ea typeface="PingFang TC"/>
               </a:rPr>
-              <a:t>How the shipped model is trained</a:t>
+              <a:t>Date holdout — unseen 42,714 frames</a:t>
             </a:r>
           </a:p>
           <a:p>
@@ -6933,7 +6933,7 @@
                 <a:latin typeface="Helvetica Neue"/>
                 <a:ea typeface="PingFang TC"/>
               </a:rPr>
-              <a:t>Logistic regression, scaler folded into coef/intercept — one dot product in Python and JS</a:t>
+              <a:t>GroupShuffleSplit 80/20 by YYMMDD · train-split fit, no full-data refit</a:t>
             </a:r>
           </a:p>
         </p:txBody>
@@ -6947,8 +6947,8 @@
           <p:nvPr/>
         </p:nvGraphicFramePr>
         <p:xfrm>
-          <a:off x="502920" y="1417320"/>
-          <a:ext cx="11155680" cy="2688336"/>
+          <a:off x="457200" y="1417320"/>
+          <a:ext cx="9555480" cy="3072384"/>
         </p:xfrm>
         <a:graphic>
           <a:graphicData uri="http://schemas.openxmlformats.org/drawingml/2006/table">
@@ -6957,11 +6957,15 @@
                 <a:tableStyleId>{5C22544A-7EE6-4342-B048-85BDC9FD1C3A}</a:tableStyleId>
               </a:tblPr>
               <a:tblGrid>
-                <a:gridCol w="1554480"/>
-                <a:gridCol w="4663440"/>
-                <a:gridCol w="4937760"/>
+                <a:gridCol w="1965960"/>
+                <a:gridCol w="640080"/>
+                <a:gridCol w="777240"/>
+                <a:gridCol w="685800"/>
+                <a:gridCol w="640080"/>
+                <a:gridCol w="640080"/>
+                <a:gridCol w="4206240"/>
               </a:tblGrid>
-              <a:tr h="384048">
+              <a:tr h="438912">
                 <a:tc>
                   <a:txBody>
                     <a:bodyPr/>
@@ -6976,7 +6980,7 @@
                         </a:defRPr>
                       </a:pPr>
                       <a:r>
-                        <a:t>Piece</a:t>
+                        <a:t>Slice</a:t>
                       </a:r>
                     </a:p>
                   </a:txBody>
@@ -7000,7 +7004,7 @@
                         </a:defRPr>
                       </a:pPr>
                       <a:r>
-                        <a:t>Choice</a:t>
+                        <a:t>n</a:t>
                       </a:r>
                     </a:p>
                   </a:txBody>
@@ -7024,7 +7028,103 @@
                         </a:defRPr>
                       </a:pPr>
                       <a:r>
-                        <a:t>Why</a:t>
+                        <a:t>Acc</a:t>
+                      </a:r>
+                    </a:p>
+                  </a:txBody>
+                  <a:tcPr>
+                    <a:solidFill>
+                      <a:srgbClr val="142A3E"/>
+                    </a:solidFill>
+                  </a:tcPr>
+                </a:tc>
+                <a:tc>
+                  <a:txBody>
+                    <a:bodyPr/>
+                    <a:lstStyle/>
+                    <a:p>
+                      <a:pPr>
+                        <a:defRPr sz="1200" b="1">
+                          <a:solidFill>
+                            <a:srgbClr val="FFFFFF"/>
+                          </a:solidFill>
+                          <a:latin typeface="Helvetica Neue"/>
+                        </a:defRPr>
+                      </a:pPr>
+                      <a:r>
+                        <a:t>P</a:t>
+                      </a:r>
+                    </a:p>
+                  </a:txBody>
+                  <a:tcPr>
+                    <a:solidFill>
+                      <a:srgbClr val="142A3E"/>
+                    </a:solidFill>
+                  </a:tcPr>
+                </a:tc>
+                <a:tc>
+                  <a:txBody>
+                    <a:bodyPr/>
+                    <a:lstStyle/>
+                    <a:p>
+                      <a:pPr>
+                        <a:defRPr sz="1200" b="1">
+                          <a:solidFill>
+                            <a:srgbClr val="FFFFFF"/>
+                          </a:solidFill>
+                          <a:latin typeface="Helvetica Neue"/>
+                        </a:defRPr>
+                      </a:pPr>
+                      <a:r>
+                        <a:t>R</a:t>
+                      </a:r>
+                    </a:p>
+                  </a:txBody>
+                  <a:tcPr>
+                    <a:solidFill>
+                      <a:srgbClr val="142A3E"/>
+                    </a:solidFill>
+                  </a:tcPr>
+                </a:tc>
+                <a:tc>
+                  <a:txBody>
+                    <a:bodyPr/>
+                    <a:lstStyle/>
+                    <a:p>
+                      <a:pPr>
+                        <a:defRPr sz="1200" b="1">
+                          <a:solidFill>
+                            <a:srgbClr val="FFFFFF"/>
+                          </a:solidFill>
+                          <a:latin typeface="Helvetica Neue"/>
+                        </a:defRPr>
+                      </a:pPr>
+                      <a:r>
+                        <a:t>F1</a:t>
+                      </a:r>
+                    </a:p>
+                  </a:txBody>
+                  <a:tcPr>
+                    <a:solidFill>
+                      <a:srgbClr val="142A3E"/>
+                    </a:solidFill>
+                  </a:tcPr>
+                </a:tc>
+                <a:tc>
+                  <a:txBody>
+                    <a:bodyPr/>
+                    <a:lstStyle/>
+                    <a:p>
+                      <a:pPr>
+                        <a:defRPr sz="1200" b="1">
+                          <a:solidFill>
+                            <a:srgbClr val="FFFFFF"/>
+                          </a:solidFill>
+                          <a:latin typeface="Helvetica Neue"/>
+                        </a:defRPr>
+                      </a:pPr>
+                      <a:r>
+                        <a:t>Confusion [[TN,FP],[FN,TP]]</a:t>
                       </a:r>
                     </a:p>
                   </a:txBody>
@@ -7035,7 +7135,7 @@
                   </a:tcPr>
                 </a:tc>
               </a:tr>
-              <a:tr h="384048">
+              <a:tr h="438912">
                 <a:tc>
                   <a:txBody>
                     <a:bodyPr/>
@@ -7050,7 +7150,7 @@
                         </a:defRPr>
                       </a:pPr>
                       <a:r>
-                        <a:t>Model</a:t>
+                        <a:t>All test</a:t>
                       </a:r>
                     </a:p>
                   </a:txBody>
@@ -7070,7 +7170,7 @@
                         </a:defRPr>
                       </a:pPr>
                       <a:r>
-                        <a:t>LogReg, C=0.5, class_weight=balanced</a:t>
+                        <a:t>42714</a:t>
                       </a:r>
                     </a:p>
                   </a:txBody>
@@ -7090,14 +7190,12 @@
                         </a:defRPr>
                       </a:pPr>
                       <a:r>
-                        <a:t>Tiny, inspectable, identical in the browser</a:t>
+                        <a:t>97.8%</a:t>
                       </a:r>
                     </a:p>
                   </a:txBody>
                   <a:tcPr/>
                 </a:tc>
-              </a:tr>
-              <a:tr h="384048">
                 <a:tc>
                   <a:txBody>
                     <a:bodyPr/>
@@ -7112,7 +7210,89 @@
                         </a:defRPr>
                       </a:pPr>
                       <a:r>
-                        <a:t>Features</a:t>
+                        <a:t>0.843</a:t>
+                      </a:r>
+                    </a:p>
+                  </a:txBody>
+                  <a:tcPr/>
+                </a:tc>
+                <a:tc>
+                  <a:txBody>
+                    <a:bodyPr/>
+                    <a:lstStyle/>
+                    <a:p>
+                      <a:pPr>
+                        <a:defRPr sz="1200" b="0">
+                          <a:solidFill>
+                            <a:srgbClr val="22303C"/>
+                          </a:solidFill>
+                          <a:latin typeface="Helvetica Neue"/>
+                        </a:defRPr>
+                      </a:pPr>
+                      <a:r>
+                        <a:t>0.996</a:t>
+                      </a:r>
+                    </a:p>
+                  </a:txBody>
+                  <a:tcPr/>
+                </a:tc>
+                <a:tc>
+                  <a:txBody>
+                    <a:bodyPr/>
+                    <a:lstStyle/>
+                    <a:p>
+                      <a:pPr>
+                        <a:defRPr sz="1200" b="0">
+                          <a:solidFill>
+                            <a:srgbClr val="22303C"/>
+                          </a:solidFill>
+                          <a:latin typeface="Helvetica Neue"/>
+                        </a:defRPr>
+                      </a:pPr>
+                      <a:r>
+                        <a:t>0.913</a:t>
+                      </a:r>
+                    </a:p>
+                  </a:txBody>
+                  <a:tcPr/>
+                </a:tc>
+                <a:tc>
+                  <a:txBody>
+                    <a:bodyPr/>
+                    <a:lstStyle/>
+                    <a:p>
+                      <a:pPr>
+                        <a:defRPr sz="1200" b="0">
+                          <a:solidFill>
+                            <a:srgbClr val="22303C"/>
+                          </a:solidFill>
+                          <a:latin typeface="Helvetica Neue"/>
+                        </a:defRPr>
+                      </a:pPr>
+                      <a:r>
+                        <a:t>[[36926, 907], [19, 4862]]</a:t>
+                      </a:r>
+                    </a:p>
+                  </a:txBody>
+                  <a:tcPr/>
+                </a:tc>
+              </a:tr>
+              <a:tr h="438912">
+                <a:tc>
+                  <a:txBody>
+                    <a:bodyPr/>
+                    <a:lstStyle/>
+                    <a:p>
+                      <a:pPr>
+                        <a:defRPr sz="1200" b="0">
+                          <a:solidFill>
+                            <a:srgbClr val="22303C"/>
+                          </a:solidFill>
+                          <a:latin typeface="Helvetica Neue"/>
+                        </a:defRPr>
+                      </a:pPr>
+                      <a:r>
+                        <a:t>Golden 2016</a:t>
                       </a:r>
                     </a:p>
                   </a:txBody>
@@ -7136,7 +7316,7 @@
                         </a:defRPr>
                       </a:pPr>
                       <a:r>
-                        <a:t>9 (no edge_density)</a:t>
+                        <a:t>46</a:t>
                       </a:r>
                     </a:p>
                   </a:txBody>
@@ -7160,95 +7340,7 @@
                         </a:defRPr>
                       </a:pPr>
                       <a:r>
-                        <a:t>Browser does not compute a Laplacian</a:t>
-                      </a:r>
-                    </a:p>
-                  </a:txBody>
-                  <a:tcPr>
-                    <a:solidFill>
-                      <a:srgbClr val="F7FAFC"/>
-                    </a:solidFill>
-                  </a:tcPr>
-                </a:tc>
-              </a:tr>
-              <a:tr h="384048">
-                <a:tc>
-                  <a:txBody>
-                    <a:bodyPr/>
-                    <a:lstStyle/>
-                    <a:p>
-                      <a:pPr>
-                        <a:defRPr sz="1200" b="0">
-                          <a:solidFill>
-                            <a:srgbClr val="22303C"/>
-                          </a:solidFill>
-                          <a:latin typeface="Helvetica Neue"/>
-                        </a:defRPr>
-                      </a:pPr>
-                      <a:r>
-                        <a:t>Fit pool</a:t>
-                      </a:r>
-                    </a:p>
-                  </a:txBody>
-                  <a:tcPr/>
-                </a:tc>
-                <a:tc>
-                  <a:txBody>
-                    <a:bodyPr/>
-                    <a:lstStyle/>
-                    <a:p>
-                      <a:pPr>
-                        <a:defRPr sz="1200" b="0">
-                          <a:solidFill>
-                            <a:srgbClr val="22303C"/>
-                          </a:solidFill>
-                          <a:latin typeface="Helvetica Neue"/>
-                        </a:defRPr>
-                      </a:pPr>
-                      <a:r>
-                        <a:t>8,354 unique / 357 dates / 704 inside</a:t>
-                      </a:r>
-                    </a:p>
-                  </a:txBody>
-                  <a:tcPr/>
-                </a:tc>
-                <a:tc>
-                  <a:txBody>
-                    <a:bodyPr/>
-                    <a:lstStyle/>
-                    <a:p>
-                      <a:pPr>
-                        <a:defRPr sz="1200" b="0">
-                          <a:solidFill>
-                            <a:srgbClr val="22303C"/>
-                          </a:solidFill>
-                          <a:latin typeface="Helvetica Neue"/>
-                        </a:defRPr>
-                      </a:pPr>
-                      <a:r>
-                        <a:t>142 golden + 8,101 hourly + 111 visual</a:t>
-                      </a:r>
-                    </a:p>
-                  </a:txBody>
-                  <a:tcPr/>
-                </a:tc>
-              </a:tr>
-              <a:tr h="384048">
-                <a:tc>
-                  <a:txBody>
-                    <a:bodyPr/>
-                    <a:lstStyle/>
-                    <a:p>
-                      <a:pPr>
-                        <a:defRPr sz="1200" b="0">
-                          <a:solidFill>
-                            <a:srgbClr val="22303C"/>
-                          </a:solidFill>
-                          <a:latin typeface="Helvetica Neue"/>
-                        </a:defRPr>
-                      </a:pPr>
-                      <a:r>
-                        <a:t>Train / test</a:t>
+                        <a:t>93.5%</a:t>
                       </a:r>
                     </a:p>
                   </a:txBody>
@@ -7272,7 +7364,7 @@
                         </a:defRPr>
                       </a:pPr>
                       <a:r>
-                        <a:t>6,652 / 1,702  (285 / 72 dates)</a:t>
+                        <a:t>0.700</a:t>
                       </a:r>
                     </a:p>
                   </a:txBody>
@@ -7296,95 +7388,7 @@
                         </a:defRPr>
                       </a:pPr>
                       <a:r>
-                        <a:t>Human x20, hourly x1, train-split fit</a:t>
-                      </a:r>
-                    </a:p>
-                  </a:txBody>
-                  <a:tcPr>
-                    <a:solidFill>
-                      <a:srgbClr val="F7FAFC"/>
-                    </a:solidFill>
-                  </a:tcPr>
-                </a:tc>
-              </a:tr>
-              <a:tr h="384048">
-                <a:tc>
-                  <a:txBody>
-                    <a:bodyPr/>
-                    <a:lstStyle/>
-                    <a:p>
-                      <a:pPr>
-                        <a:defRPr sz="1200" b="0">
-                          <a:solidFill>
-                            <a:srgbClr val="22303C"/>
-                          </a:solidFill>
-                          <a:latin typeface="Helvetica Neue"/>
-                        </a:defRPr>
-                      </a:pPr>
-                      <a:r>
-                        <a:t>Split</a:t>
-                      </a:r>
-                    </a:p>
-                  </a:txBody>
-                  <a:tcPr/>
-                </a:tc>
-                <a:tc>
-                  <a:txBody>
-                    <a:bodyPr/>
-                    <a:lstStyle/>
-                    <a:p>
-                      <a:pPr>
-                        <a:defRPr sz="1200" b="0">
-                          <a:solidFill>
-                            <a:srgbClr val="22303C"/>
-                          </a:solidFill>
-                          <a:latin typeface="Helvetica Neue"/>
-                        </a:defRPr>
-                      </a:pPr>
-                      <a:r>
-                        <a:t>GroupShuffleSplit by date, rs=42</a:t>
-                      </a:r>
-                    </a:p>
-                  </a:txBody>
-                  <a:tcPr/>
-                </a:tc>
-                <a:tc>
-                  <a:txBody>
-                    <a:bodyPr/>
-                    <a:lstStyle/>
-                    <a:p>
-                      <a:pPr>
-                        <a:defRPr sz="1200" b="0">
-                          <a:solidFill>
-                            <a:srgbClr val="22303C"/>
-                          </a:solidFill>
-                          <a:latin typeface="Helvetica Neue"/>
-                        </a:defRPr>
-                      </a:pPr>
-                      <a:r>
-                        <a:t>Nearby frames would leak otherwise</a:t>
-                      </a:r>
-                    </a:p>
-                  </a:txBody>
-                  <a:tcPr/>
-                </a:tc>
-              </a:tr>
-              <a:tr h="384048">
-                <a:tc>
-                  <a:txBody>
-                    <a:bodyPr/>
-                    <a:lstStyle/>
-                    <a:p>
-                      <a:pPr>
-                        <a:defRPr sz="1200" b="0">
-                          <a:solidFill>
-                            <a:srgbClr val="22303C"/>
-                          </a:solidFill>
-                          <a:latin typeface="Helvetica Neue"/>
-                        </a:defRPr>
-                      </a:pPr>
-                      <a:r>
-                        <a:t>Export</a:t>
+                        <a:t>1.000</a:t>
                       </a:r>
                     </a:p>
                   </a:txBody>
@@ -7408,7 +7412,7 @@
                         </a:defRPr>
                       </a:pPr>
                       <a:r>
-                        <a:t>models/ + docs/ cloud_logreg.json</a:t>
+                        <a:t>0.824</a:t>
                       </a:r>
                     </a:p>
                   </a:txBody>
@@ -7432,7 +7436,631 @@
                         </a:defRPr>
                       </a:pPr>
                       <a:r>
-                        <a:t>Pages, Flask, CLI, live Action share weights</a:t>
+                        <a:t>[[36, 3], [0, 7]]</a:t>
+                      </a:r>
+                    </a:p>
+                  </a:txBody>
+                  <a:tcPr>
+                    <a:solidFill>
+                      <a:srgbClr val="F7FAFC"/>
+                    </a:solidFill>
+                  </a:tcPr>
+                </a:tc>
+              </a:tr>
+              <a:tr h="438912">
+                <a:tc>
+                  <a:txBody>
+                    <a:bodyPr/>
+                    <a:lstStyle/>
+                    <a:p>
+                      <a:pPr>
+                        <a:defRPr sz="1200" b="0">
+                          <a:solidFill>
+                            <a:srgbClr val="22303C"/>
+                          </a:solidFill>
+                          <a:latin typeface="Helvetica Neue"/>
+                        </a:defRPr>
+                      </a:pPr>
+                      <a:r>
+                        <a:t>R5 hourly seed</a:t>
+                      </a:r>
+                    </a:p>
+                  </a:txBody>
+                  <a:tcPr/>
+                </a:tc>
+                <a:tc>
+                  <a:txBody>
+                    <a:bodyPr/>
+                    <a:lstStyle/>
+                    <a:p>
+                      <a:pPr>
+                        <a:defRPr sz="1200" b="0">
+                          <a:solidFill>
+                            <a:srgbClr val="22303C"/>
+                          </a:solidFill>
+                          <a:latin typeface="Helvetica Neue"/>
+                        </a:defRPr>
+                      </a:pPr>
+                      <a:r>
+                        <a:t>1636</a:t>
+                      </a:r>
+                    </a:p>
+                  </a:txBody>
+                  <a:tcPr/>
+                </a:tc>
+                <a:tc>
+                  <a:txBody>
+                    <a:bodyPr/>
+                    <a:lstStyle/>
+                    <a:p>
+                      <a:pPr>
+                        <a:defRPr sz="1200" b="0">
+                          <a:solidFill>
+                            <a:srgbClr val="22303C"/>
+                          </a:solidFill>
+                          <a:latin typeface="Helvetica Neue"/>
+                        </a:defRPr>
+                      </a:pPr>
+                      <a:r>
+                        <a:t>96.9%</a:t>
+                      </a:r>
+                    </a:p>
+                  </a:txBody>
+                  <a:tcPr/>
+                </a:tc>
+                <a:tc>
+                  <a:txBody>
+                    <a:bodyPr/>
+                    <a:lstStyle/>
+                    <a:p>
+                      <a:pPr>
+                        <a:defRPr sz="1200" b="0">
+                          <a:solidFill>
+                            <a:srgbClr val="22303C"/>
+                          </a:solidFill>
+                          <a:latin typeface="Helvetica Neue"/>
+                        </a:defRPr>
+                      </a:pPr>
+                      <a:r>
+                        <a:t>0.728</a:t>
+                      </a:r>
+                    </a:p>
+                  </a:txBody>
+                  <a:tcPr/>
+                </a:tc>
+                <a:tc>
+                  <a:txBody>
+                    <a:bodyPr/>
+                    <a:lstStyle/>
+                    <a:p>
+                      <a:pPr>
+                        <a:defRPr sz="1200" b="0">
+                          <a:solidFill>
+                            <a:srgbClr val="22303C"/>
+                          </a:solidFill>
+                          <a:latin typeface="Helvetica Neue"/>
+                        </a:defRPr>
+                      </a:pPr>
+                      <a:r>
+                        <a:t>0.977</a:t>
+                      </a:r>
+                    </a:p>
+                  </a:txBody>
+                  <a:tcPr/>
+                </a:tc>
+                <a:tc>
+                  <a:txBody>
+                    <a:bodyPr/>
+                    <a:lstStyle/>
+                    <a:p>
+                      <a:pPr>
+                        <a:defRPr sz="1200" b="0">
+                          <a:solidFill>
+                            <a:srgbClr val="22303C"/>
+                          </a:solidFill>
+                          <a:latin typeface="Helvetica Neue"/>
+                        </a:defRPr>
+                      </a:pPr>
+                      <a:r>
+                        <a:t>0.834</a:t>
+                      </a:r>
+                    </a:p>
+                  </a:txBody>
+                  <a:tcPr/>
+                </a:tc>
+                <a:tc>
+                  <a:txBody>
+                    <a:bodyPr/>
+                    <a:lstStyle/>
+                    <a:p>
+                      <a:pPr>
+                        <a:defRPr sz="1200" b="0">
+                          <a:solidFill>
+                            <a:srgbClr val="22303C"/>
+                          </a:solidFill>
+                          <a:latin typeface="Helvetica Neue"/>
+                        </a:defRPr>
+                      </a:pPr>
+                      <a:r>
+                        <a:t>[[1460, 47], [3, 126]]</a:t>
+                      </a:r>
+                    </a:p>
+                  </a:txBody>
+                  <a:tcPr/>
+                </a:tc>
+              </a:tr>
+              <a:tr h="438912">
+                <a:tc>
+                  <a:txBody>
+                    <a:bodyPr/>
+                    <a:lstStyle/>
+                    <a:p>
+                      <a:pPr>
+                        <a:defRPr sz="1200" b="0">
+                          <a:solidFill>
+                            <a:srgbClr val="22303C"/>
+                          </a:solidFill>
+                          <a:latin typeface="Helvetica Neue"/>
+                        </a:defRPr>
+                      </a:pPr>
+                      <a:r>
+                        <a:t>111 on test dates</a:t>
+                      </a:r>
+                    </a:p>
+                  </a:txBody>
+                  <a:tcPr>
+                    <a:solidFill>
+                      <a:srgbClr val="F7FAFC"/>
+                    </a:solidFill>
+                  </a:tcPr>
+                </a:tc>
+                <a:tc>
+                  <a:txBody>
+                    <a:bodyPr/>
+                    <a:lstStyle/>
+                    <a:p>
+                      <a:pPr>
+                        <a:defRPr sz="1200" b="0">
+                          <a:solidFill>
+                            <a:srgbClr val="22303C"/>
+                          </a:solidFill>
+                          <a:latin typeface="Helvetica Neue"/>
+                        </a:defRPr>
+                      </a:pPr>
+                      <a:r>
+                        <a:t>20</a:t>
+                      </a:r>
+                    </a:p>
+                  </a:txBody>
+                  <a:tcPr>
+                    <a:solidFill>
+                      <a:srgbClr val="F7FAFC"/>
+                    </a:solidFill>
+                  </a:tcPr>
+                </a:tc>
+                <a:tc>
+                  <a:txBody>
+                    <a:bodyPr/>
+                    <a:lstStyle/>
+                    <a:p>
+                      <a:pPr>
+                        <a:defRPr sz="1200" b="0">
+                          <a:solidFill>
+                            <a:srgbClr val="22303C"/>
+                          </a:solidFill>
+                          <a:latin typeface="Helvetica Neue"/>
+                        </a:defRPr>
+                      </a:pPr>
+                      <a:r>
+                        <a:t>75.0%</a:t>
+                      </a:r>
+                    </a:p>
+                  </a:txBody>
+                  <a:tcPr>
+                    <a:solidFill>
+                      <a:srgbClr val="F7FAFC"/>
+                    </a:solidFill>
+                  </a:tcPr>
+                </a:tc>
+                <a:tc>
+                  <a:txBody>
+                    <a:bodyPr/>
+                    <a:lstStyle/>
+                    <a:p>
+                      <a:pPr>
+                        <a:defRPr sz="1200" b="0">
+                          <a:solidFill>
+                            <a:srgbClr val="22303C"/>
+                          </a:solidFill>
+                          <a:latin typeface="Helvetica Neue"/>
+                        </a:defRPr>
+                      </a:pPr>
+                      <a:r>
+                        <a:t>0.688</a:t>
+                      </a:r>
+                    </a:p>
+                  </a:txBody>
+                  <a:tcPr>
+                    <a:solidFill>
+                      <a:srgbClr val="F7FAFC"/>
+                    </a:solidFill>
+                  </a:tcPr>
+                </a:tc>
+                <a:tc>
+                  <a:txBody>
+                    <a:bodyPr/>
+                    <a:lstStyle/>
+                    <a:p>
+                      <a:pPr>
+                        <a:defRPr sz="1200" b="0">
+                          <a:solidFill>
+                            <a:srgbClr val="22303C"/>
+                          </a:solidFill>
+                          <a:latin typeface="Helvetica Neue"/>
+                        </a:defRPr>
+                      </a:pPr>
+                      <a:r>
+                        <a:t>1.000</a:t>
+                      </a:r>
+                    </a:p>
+                  </a:txBody>
+                  <a:tcPr>
+                    <a:solidFill>
+                      <a:srgbClr val="F7FAFC"/>
+                    </a:solidFill>
+                  </a:tcPr>
+                </a:tc>
+                <a:tc>
+                  <a:txBody>
+                    <a:bodyPr/>
+                    <a:lstStyle/>
+                    <a:p>
+                      <a:pPr>
+                        <a:defRPr sz="1200" b="0">
+                          <a:solidFill>
+                            <a:srgbClr val="22303C"/>
+                          </a:solidFill>
+                          <a:latin typeface="Helvetica Neue"/>
+                        </a:defRPr>
+                      </a:pPr>
+                      <a:r>
+                        <a:t>0.815</a:t>
+                      </a:r>
+                    </a:p>
+                  </a:txBody>
+                  <a:tcPr>
+                    <a:solidFill>
+                      <a:srgbClr val="F7FAFC"/>
+                    </a:solidFill>
+                  </a:tcPr>
+                </a:tc>
+                <a:tc>
+                  <a:txBody>
+                    <a:bodyPr/>
+                    <a:lstStyle/>
+                    <a:p>
+                      <a:pPr>
+                        <a:defRPr sz="1200" b="0">
+                          <a:solidFill>
+                            <a:srgbClr val="22303C"/>
+                          </a:solidFill>
+                          <a:latin typeface="Helvetica Neue"/>
+                        </a:defRPr>
+                      </a:pPr>
+                      <a:r>
+                        <a:t>[[4, 5], [0, 11]]</a:t>
+                      </a:r>
+                    </a:p>
+                  </a:txBody>
+                  <a:tcPr>
+                    <a:solidFill>
+                      <a:srgbClr val="F7FAFC"/>
+                    </a:solidFill>
+                  </a:tcPr>
+                </a:tc>
+              </a:tr>
+              <a:tr h="438912">
+                <a:tc>
+                  <a:txBody>
+                    <a:bodyPr/>
+                    <a:lstStyle/>
+                    <a:p>
+                      <a:pPr>
+                        <a:defRPr sz="1200" b="0">
+                          <a:solidFill>
+                            <a:srgbClr val="22303C"/>
+                          </a:solidFill>
+                          <a:latin typeface="Helvetica Neue"/>
+                        </a:defRPr>
+                      </a:pPr>
+                      <a:r>
+                        <a:t>Train (ref.)</a:t>
+                      </a:r>
+                    </a:p>
+                  </a:txBody>
+                  <a:tcPr/>
+                </a:tc>
+                <a:tc>
+                  <a:txBody>
+                    <a:bodyPr/>
+                    <a:lstStyle/>
+                    <a:p>
+                      <a:pPr>
+                        <a:defRPr sz="1200" b="0">
+                          <a:solidFill>
+                            <a:srgbClr val="22303C"/>
+                          </a:solidFill>
+                          <a:latin typeface="Helvetica Neue"/>
+                        </a:defRPr>
+                      </a:pPr>
+                      <a:r>
+                        <a:t>129629</a:t>
+                      </a:r>
+                    </a:p>
+                  </a:txBody>
+                  <a:tcPr/>
+                </a:tc>
+                <a:tc>
+                  <a:txBody>
+                    <a:bodyPr/>
+                    <a:lstStyle/>
+                    <a:p>
+                      <a:pPr>
+                        <a:defRPr sz="1200" b="0">
+                          <a:solidFill>
+                            <a:srgbClr val="22303C"/>
+                          </a:solidFill>
+                          <a:latin typeface="Helvetica Neue"/>
+                        </a:defRPr>
+                      </a:pPr>
+                      <a:r>
+                        <a:t>96.9%</a:t>
+                      </a:r>
+                    </a:p>
+                  </a:txBody>
+                  <a:tcPr/>
+                </a:tc>
+                <a:tc>
+                  <a:txBody>
+                    <a:bodyPr/>
+                    <a:lstStyle/>
+                    <a:p>
+                      <a:pPr>
+                        <a:defRPr sz="1200" b="0">
+                          <a:solidFill>
+                            <a:srgbClr val="22303C"/>
+                          </a:solidFill>
+                          <a:latin typeface="Helvetica Neue"/>
+                        </a:defRPr>
+                      </a:pPr>
+                      <a:r>
+                        <a:t>0.819</a:t>
+                      </a:r>
+                    </a:p>
+                  </a:txBody>
+                  <a:tcPr/>
+                </a:tc>
+                <a:tc>
+                  <a:txBody>
+                    <a:bodyPr/>
+                    <a:lstStyle/>
+                    <a:p>
+                      <a:pPr>
+                        <a:defRPr sz="1200" b="0">
+                          <a:solidFill>
+                            <a:srgbClr val="22303C"/>
+                          </a:solidFill>
+                          <a:latin typeface="Helvetica Neue"/>
+                        </a:defRPr>
+                      </a:pPr>
+                      <a:r>
+                        <a:t>0.977</a:t>
+                      </a:r>
+                    </a:p>
+                  </a:txBody>
+                  <a:tcPr/>
+                </a:tc>
+                <a:tc>
+                  <a:txBody>
+                    <a:bodyPr/>
+                    <a:lstStyle/>
+                    <a:p>
+                      <a:pPr>
+                        <a:defRPr sz="1200" b="0">
+                          <a:solidFill>
+                            <a:srgbClr val="22303C"/>
+                          </a:solidFill>
+                          <a:latin typeface="Helvetica Neue"/>
+                        </a:defRPr>
+                      </a:pPr>
+                      <a:r>
+                        <a:t>0.891</a:t>
+                      </a:r>
+                    </a:p>
+                  </a:txBody>
+                  <a:tcPr/>
+                </a:tc>
+                <a:tc>
+                  <a:txBody>
+                    <a:bodyPr/>
+                    <a:lstStyle/>
+                    <a:p>
+                      <a:pPr>
+                        <a:defRPr sz="1200" b="0">
+                          <a:solidFill>
+                            <a:srgbClr val="22303C"/>
+                          </a:solidFill>
+                          <a:latin typeface="Helvetica Neue"/>
+                        </a:defRPr>
+                      </a:pPr>
+                      <a:r>
+                        <a:t>[[109314, 3613], [393, 16309]]</a:t>
+                      </a:r>
+                    </a:p>
+                  </a:txBody>
+                  <a:tcPr/>
+                </a:tc>
+              </a:tr>
+              <a:tr h="438912">
+                <a:tc>
+                  <a:txBody>
+                    <a:bodyPr/>
+                    <a:lstStyle/>
+                    <a:p>
+                      <a:pPr>
+                        <a:defRPr sz="1200" b="0">
+                          <a:solidFill>
+                            <a:srgbClr val="22303C"/>
+                          </a:solidFill>
+                          <a:latin typeface="Helvetica Neue"/>
+                        </a:defRPr>
+                      </a:pPr>
+                      <a:r>
+                        <a:t>d413d74, same test</a:t>
+                      </a:r>
+                    </a:p>
+                  </a:txBody>
+                  <a:tcPr>
+                    <a:solidFill>
+                      <a:srgbClr val="F7FAFC"/>
+                    </a:solidFill>
+                  </a:tcPr>
+                </a:tc>
+                <a:tc>
+                  <a:txBody>
+                    <a:bodyPr/>
+                    <a:lstStyle/>
+                    <a:p>
+                      <a:pPr>
+                        <a:defRPr sz="1200" b="0">
+                          <a:solidFill>
+                            <a:srgbClr val="22303C"/>
+                          </a:solidFill>
+                          <a:latin typeface="Helvetica Neue"/>
+                        </a:defRPr>
+                      </a:pPr>
+                      <a:r>
+                        <a:t>42714</a:t>
+                      </a:r>
+                    </a:p>
+                  </a:txBody>
+                  <a:tcPr>
+                    <a:solidFill>
+                      <a:srgbClr val="F7FAFC"/>
+                    </a:solidFill>
+                  </a:tcPr>
+                </a:tc>
+                <a:tc>
+                  <a:txBody>
+                    <a:bodyPr/>
+                    <a:lstStyle/>
+                    <a:p>
+                      <a:pPr>
+                        <a:defRPr sz="1200" b="0">
+                          <a:solidFill>
+                            <a:srgbClr val="22303C"/>
+                          </a:solidFill>
+                          <a:latin typeface="Helvetica Neue"/>
+                        </a:defRPr>
+                      </a:pPr>
+                      <a:r>
+                        <a:t>98.0%</a:t>
+                      </a:r>
+                    </a:p>
+                  </a:txBody>
+                  <a:tcPr>
+                    <a:solidFill>
+                      <a:srgbClr val="F7FAFC"/>
+                    </a:solidFill>
+                  </a:tcPr>
+                </a:tc>
+                <a:tc>
+                  <a:txBody>
+                    <a:bodyPr/>
+                    <a:lstStyle/>
+                    <a:p>
+                      <a:pPr>
+                        <a:defRPr sz="1200" b="0">
+                          <a:solidFill>
+                            <a:srgbClr val="22303C"/>
+                          </a:solidFill>
+                          <a:latin typeface="Helvetica Neue"/>
+                        </a:defRPr>
+                      </a:pPr>
+                      <a:r>
+                        <a:t>0.856</a:t>
+                      </a:r>
+                    </a:p>
+                  </a:txBody>
+                  <a:tcPr>
+                    <a:solidFill>
+                      <a:srgbClr val="F7FAFC"/>
+                    </a:solidFill>
+                  </a:tcPr>
+                </a:tc>
+                <a:tc>
+                  <a:txBody>
+                    <a:bodyPr/>
+                    <a:lstStyle/>
+                    <a:p>
+                      <a:pPr>
+                        <a:defRPr sz="1200" b="0">
+                          <a:solidFill>
+                            <a:srgbClr val="22303C"/>
+                          </a:solidFill>
+                          <a:latin typeface="Helvetica Neue"/>
+                        </a:defRPr>
+                      </a:pPr>
+                      <a:r>
+                        <a:t>0.996</a:t>
+                      </a:r>
+                    </a:p>
+                  </a:txBody>
+                  <a:tcPr>
+                    <a:solidFill>
+                      <a:srgbClr val="F7FAFC"/>
+                    </a:solidFill>
+                  </a:tcPr>
+                </a:tc>
+                <a:tc>
+                  <a:txBody>
+                    <a:bodyPr/>
+                    <a:lstStyle/>
+                    <a:p>
+                      <a:pPr>
+                        <a:defRPr sz="1200" b="0">
+                          <a:solidFill>
+                            <a:srgbClr val="22303C"/>
+                          </a:solidFill>
+                          <a:latin typeface="Helvetica Neue"/>
+                        </a:defRPr>
+                      </a:pPr>
+                      <a:r>
+                        <a:t>0.921</a:t>
+                      </a:r>
+                    </a:p>
+                  </a:txBody>
+                  <a:tcPr>
+                    <a:solidFill>
+                      <a:srgbClr val="F7FAFC"/>
+                    </a:solidFill>
+                  </a:tcPr>
+                </a:tc>
+                <a:tc>
+                  <a:txBody>
+                    <a:bodyPr/>
+                    <a:lstStyle/>
+                    <a:p>
+                      <a:pPr>
+                        <a:defRPr sz="1200" b="0">
+                          <a:solidFill>
+                            <a:srgbClr val="22303C"/>
+                          </a:solidFill>
+                          <a:latin typeface="Helvetica Neue"/>
+                        </a:defRPr>
+                      </a:pPr>
+                      <a:r>
+                        <a:t>[[37018, 815], [19, 4862]]</a:t>
                       </a:r>
                     </a:p>
                   </a:txBody>
@@ -7455,8 +8083,8 @@
         </p:nvSpPr>
         <p:spPr>
           <a:xfrm>
-            <a:off x="502920" y="4709160"/>
-            <a:ext cx="5486400" cy="1554480"/>
+            <a:off x="502920" y="5074920"/>
+            <a:ext cx="11201400" cy="1143000"/>
           </a:xfrm>
           <a:prstGeom prst="roundRect">
             <a:avLst>
@@ -7464,7 +8092,7 @@
             </a:avLst>
           </a:prstGeom>
           <a:solidFill>
-            <a:srgbClr val="E6F3EB"/>
+            <a:srgbClr val="E3EFF8"/>
           </a:solidFill>
           <a:ln>
             <a:noFill/>
@@ -7501,8 +8129,8 @@
         </p:nvSpPr>
         <p:spPr>
           <a:xfrm>
-            <a:off x="731520" y="4846320"/>
-            <a:ext cx="5074920" cy="1325880"/>
+            <a:off x="777240" y="5212080"/>
+            <a:ext cx="10698480" cy="914400"/>
           </a:xfrm>
           <a:prstGeom prst="rect">
             <a:avLst/>
@@ -7521,14 +8149,14 @@
               </a:spcAft>
             </a:pPr>
             <a:r>
-              <a:rPr sz="1400" b="1">
+              <a:rPr sz="1500" b="1">
                 <a:solidFill>
                   <a:srgbClr val="142A3E"/>
                 </a:solidFill>
                 <a:latin typeface="Helvetica Neue"/>
                 <a:ea typeface="PingFang TC"/>
               </a:rPr>
-              <a:t>What the weights listen to</a:t>
+              <a:t>Read this carefully</a:t>
             </a:r>
           </a:p>
           <a:p>
@@ -7545,67 +8173,21 @@
                 <a:latin typeface="Helvetica Neue"/>
                 <a:ea typeface="PingFang TC"/>
               </a:rPr>
-              <a:t>far_wash and is_day push toward inside. saturation and far-field texture push toward not_inside — valley color and structure.</a:t>
-            </a:r>
-          </a:p>
-        </p:txBody>
-      </p:sp>
-      <p:sp>
-        <p:nvSpPr>
-          <p:cNvPr id="7" name="Rounded Rectangle 6"/>
-          <p:cNvSpPr/>
-          <p:nvPr/>
-        </p:nvSpPr>
-        <p:spPr>
-          <a:xfrm>
-            <a:off x="6172200" y="4709160"/>
-            <a:ext cx="5532120" cy="1554480"/>
-          </a:xfrm>
-          <a:prstGeom prst="roundRect">
-            <a:avLst>
-              <a:gd name="adj" fmla="val 6000"/>
-            </a:avLst>
-          </a:prstGeom>
-          <a:solidFill>
-            <a:srgbClr val="E3EFF8"/>
-          </a:solidFill>
-          <a:ln>
-            <a:noFill/>
-          </a:ln>
-          <a:effectLst/>
-        </p:spPr>
-        <p:style>
-          <a:lnRef idx="1">
-            <a:schemeClr val="accent1"/>
-          </a:lnRef>
-          <a:fillRef idx="3">
-            <a:schemeClr val="accent1"/>
-          </a:fillRef>
-          <a:effectRef idx="2">
-            <a:schemeClr val="accent1"/>
-          </a:effectRef>
-          <a:fontRef idx="minor">
-            <a:schemeClr val="lt1"/>
-          </a:fontRef>
-        </p:style>
-        <p:txBody>
-          <a:bodyPr rtlCol="0" anchor="ctr"/>
-          <a:lstStyle/>
-          <a:p>
-            <a:pPr algn="ctr"/>
-          </a:p>
-        </p:txBody>
-      </p:sp>
-      <p:sp>
-        <p:nvSpPr>
-          <p:cNvPr id="8" name="TextBox 7"/>
+              <a:t>Recall 0.996 on 42,714 unseen-date rows. Accuracy is tied with d413d74. Heuristic slices restates the rules that labeled most of the train set — trust golden and 111.</a:t>
+            </a:r>
+          </a:p>
+        </p:txBody>
+      </p:sp>
+      <p:sp>
+        <p:nvSpPr>
+          <p:cNvPr id="7" name="TextBox 6"/>
           <p:cNvSpPr txBox="1"/>
           <p:nvPr/>
         </p:nvSpPr>
         <p:spPr>
           <a:xfrm>
-            <a:off x="6400800" y="4846320"/>
-            <a:ext cx="5120640" cy="1325880"/>
+            <a:off x="502920" y="6446520"/>
+            <a:ext cx="5486400" cy="320040"/>
           </a:xfrm>
           <a:prstGeom prst="rect">
             <a:avLst/>
@@ -7620,67 +8202,10 @@
           <a:p>
             <a:pPr>
               <a:spcAft>
-                <a:spcPts val="400"/>
-              </a:spcAft>
-            </a:pPr>
-            <a:r>
-              <a:rPr sz="1400" b="1">
-                <a:solidFill>
-                  <a:srgbClr val="142A3E"/>
-                </a:solidFill>
-                <a:latin typeface="Helvetica Neue"/>
-                <a:ea typeface="PingFang TC"/>
-              </a:rPr>
-              <a:t>What we refused to ship</a:t>
-            </a:r>
-          </a:p>
-          <a:p>
-            <a:pPr>
-              <a:spcAft>
                 <a:spcPts val="600"/>
               </a:spcAft>
             </a:pPr>
             <a:r>
-              <a:rPr sz="1300" b="0">
-                <a:solidFill>
-                  <a:srgbClr val="22303C"/>
-                </a:solidFill>
-                <a:latin typeface="Helvetica Neue"/>
-                <a:ea typeface="PingFang TC"/>
-              </a:rPr>
-              <a:t>166,772 Jan-Apr minutes (and a 15-min subsample) both lost on golden and 111-photo checks vs d413d74. Four months of seed labels drown a full year.</a:t>
-            </a:r>
-          </a:p>
-        </p:txBody>
-      </p:sp>
-      <p:sp>
-        <p:nvSpPr>
-          <p:cNvPr id="9" name="TextBox 8"/>
-          <p:cNvSpPr txBox="1"/>
-          <p:nvPr/>
-        </p:nvSpPr>
-        <p:spPr>
-          <a:xfrm>
-            <a:off x="502920" y="6446520"/>
-            <a:ext cx="5486400" cy="320040"/>
-          </a:xfrm>
-          <a:prstGeom prst="rect">
-            <a:avLst/>
-          </a:prstGeom>
-          <a:noFill/>
-        </p:spPr>
-        <p:txBody>
-          <a:bodyPr wrap="square">
-            <a:spAutoFit/>
-          </a:bodyPr>
-          <a:lstStyle/>
-          <a:p>
-            <a:pPr>
-              <a:spcAft>
-                <a:spcPts val="600"/>
-              </a:spcAft>
-            </a:pPr>
-            <a:r>
               <a:rPr sz="1000" b="0">
                 <a:solidFill>
                   <a:srgbClr val="5B7083"/>
@@ -7695,7 +8220,7 @@
       </p:sp>
       <p:sp>
         <p:nvSpPr>
-          <p:cNvPr id="10" name="TextBox 9"/>
+          <p:cNvPr id="8" name="TextBox 7"/>
           <p:cNvSpPr txBox="1"/>
           <p:nvPr/>
         </p:nvSpPr>
@@ -7829,7 +8354,7 @@
                 <a:latin typeface="Helvetica Neue"/>
                 <a:ea typeface="PingFang TC"/>
               </a:rPr>
-              <a:t>Held-out test vs honest labels</a:t>
+              <a:t>111 visual 2023 photos</a:t>
             </a:r>
           </a:p>
           <a:p>
@@ -7846,400 +8371,7 @@
                 <a:latin typeface="Helvetica Neue"/>
                 <a:ea typeface="PingFang TC"/>
               </a:rPr>
-              <a:t>The 1,702-row test is mostly heuristic. Trust golden-all and the 111-photo numbers.</a:t>
-            </a:r>
-          </a:p>
-        </p:txBody>
-      </p:sp>
-      <p:pic>
-        <p:nvPicPr>
-          <p:cNvPr id="4" name="Picture 3" descr="update_acc.png"/>
-          <p:cNvPicPr>
-            <a:picLocks noChangeAspect="1"/>
-          </p:cNvPicPr>
-          <p:nvPr/>
-        </p:nvPicPr>
-        <p:blipFill>
-          <a:blip r:embed="rId2"/>
-          <a:stretch>
-            <a:fillRect/>
-          </a:stretch>
-        </p:blipFill>
-        <p:spPr>
-          <a:xfrm>
-            <a:off x="365760" y="1371600"/>
-            <a:ext cx="6858000" cy="3248526"/>
-          </a:xfrm>
-          <a:prstGeom prst="rect">
-            <a:avLst/>
-          </a:prstGeom>
-        </p:spPr>
-      </p:pic>
-      <p:sp>
-        <p:nvSpPr>
-          <p:cNvPr id="5" name="Rounded Rectangle 4"/>
-          <p:cNvSpPr/>
-          <p:nvPr/>
-        </p:nvSpPr>
-        <p:spPr>
-          <a:xfrm>
-            <a:off x="7360920" y="1417320"/>
-            <a:ext cx="4343400" cy="4709160"/>
-          </a:xfrm>
-          <a:prstGeom prst="roundRect">
-            <a:avLst>
-              <a:gd name="adj" fmla="val 6000"/>
-            </a:avLst>
-          </a:prstGeom>
-          <a:solidFill>
-            <a:srgbClr val="F2F6F9"/>
-          </a:solidFill>
-          <a:ln>
-            <a:noFill/>
-          </a:ln>
-          <a:effectLst/>
-        </p:spPr>
-        <p:style>
-          <a:lnRef idx="1">
-            <a:schemeClr val="accent1"/>
-          </a:lnRef>
-          <a:fillRef idx="3">
-            <a:schemeClr val="accent1"/>
-          </a:fillRef>
-          <a:effectRef idx="2">
-            <a:schemeClr val="accent1"/>
-          </a:effectRef>
-          <a:fontRef idx="minor">
-            <a:schemeClr val="lt1"/>
-          </a:fontRef>
-        </p:style>
-        <p:txBody>
-          <a:bodyPr rtlCol="0" anchor="ctr"/>
-          <a:lstStyle/>
-          <a:p>
-            <a:pPr algn="ctr"/>
-          </a:p>
-        </p:txBody>
-      </p:sp>
-      <p:sp>
-        <p:nvSpPr>
-          <p:cNvPr id="6" name="TextBox 5"/>
-          <p:cNvSpPr txBox="1"/>
-          <p:nvPr/>
-        </p:nvSpPr>
-        <p:spPr>
-          <a:xfrm>
-            <a:off x="7589520" y="1600200"/>
-            <a:ext cx="3931920" cy="4434840"/>
-          </a:xfrm>
-          <a:prstGeom prst="rect">
-            <a:avLst/>
-          </a:prstGeom>
-          <a:noFill/>
-        </p:spPr>
-        <p:txBody>
-          <a:bodyPr wrap="square">
-            <a:spAutoFit/>
-          </a:bodyPr>
-          <a:lstStyle/>
-          <a:p>
-            <a:pPr>
-              <a:spcAft>
-                <a:spcPts val="800"/>
-              </a:spcAft>
-            </a:pPr>
-            <a:r>
-              <a:rPr sz="1600" b="1">
-                <a:solidFill>
-                  <a:srgbClr val="142A3E"/>
-                </a:solidFill>
-                <a:latin typeface="Helvetica Neue"/>
-                <a:ea typeface="PingFang TC"/>
-              </a:rPr>
-              <a:t>Headline numbers</a:t>
-            </a:r>
-          </a:p>
-          <a:p>
-            <a:pPr>
-              <a:spcAft>
-                <a:spcPts val="600"/>
-              </a:spcAft>
-            </a:pPr>
-            <a:r>
-              <a:rPr sz="1300" b="0">
-                <a:solidFill>
-                  <a:srgbClr val="22303C"/>
-                </a:solidFill>
-                <a:latin typeface="Helvetica Neue"/>
-                <a:ea typeface="PingFang TC"/>
-              </a:rPr>
-              <a:t>•  Test 1,702 — 96.2%. Zero missed inside-cloud [[1490, 65], [0, 147]].</a:t>
-            </a:r>
-          </a:p>
-          <a:p>
-            <a:pPr>
-              <a:spcAft>
-                <a:spcPts val="600"/>
-              </a:spcAft>
-            </a:pPr>
-            <a:r>
-              <a:rPr sz="1300" b="0">
-                <a:solidFill>
-                  <a:srgbClr val="22303C"/>
-                </a:solidFill>
-                <a:latin typeface="Helvetica Neue"/>
-                <a:ea typeface="PingFang TC"/>
-              </a:rPr>
-              <a:t>•  Golden-all 142 — 97.2% vs d413d74 95.1%.</a:t>
-            </a:r>
-          </a:p>
-          <a:p>
-            <a:pPr>
-              <a:spcAft>
-                <a:spcPts val="600"/>
-              </a:spcAft>
-            </a:pPr>
-            <a:r>
-              <a:rPr sz="1300" b="0">
-                <a:solidFill>
-                  <a:srgbClr val="22303C"/>
-                </a:solidFill>
-                <a:latin typeface="Helvetica Neue"/>
-                <a:ea typeface="PingFang TC"/>
-              </a:rPr>
-              <a:t>•  Heuristic-heavy test is below d413d74 97.2%. Not the selection metric.</a:t>
-            </a:r>
-          </a:p>
-          <a:p>
-            <a:pPr>
-              <a:spcAft>
-                <a:spcPts val="800"/>
-              </a:spcAft>
-            </a:pPr>
-            <a:r>
-              <a:rPr sz="1300" b="0">
-                <a:solidFill>
-                  <a:srgbClr val="22303C"/>
-                </a:solidFill>
-                <a:latin typeface="Helvetica Neue"/>
-                <a:ea typeface="PingFang TC"/>
-              </a:rPr>
-              <a:t>•  Trainer: tools/train_final.py. Previous weights kept as cloud_logreg_d413d74.json.</a:t>
-            </a:r>
-          </a:p>
-          <a:p>
-            <a:pPr>
-              <a:spcAft>
-                <a:spcPts val="600"/>
-              </a:spcAft>
-            </a:pPr>
-            <a:r>
-              <a:rPr sz="1200" b="0">
-                <a:solidFill>
-                  <a:srgbClr val="5B7083"/>
-                </a:solidFill>
-                <a:latin typeface="Helvetica Neue"/>
-                <a:ea typeface="PingFang TC"/>
-              </a:rPr>
-              <a:t>Caveat: 91 of 111 visual dates were in the train split. 20 test-date frames: 75%.</a:t>
-            </a:r>
-          </a:p>
-        </p:txBody>
-      </p:sp>
-      <p:sp>
-        <p:nvSpPr>
-          <p:cNvPr id="7" name="TextBox 6"/>
-          <p:cNvSpPr txBox="1"/>
-          <p:nvPr/>
-        </p:nvSpPr>
-        <p:spPr>
-          <a:xfrm>
-            <a:off x="502920" y="6446520"/>
-            <a:ext cx="5486400" cy="320040"/>
-          </a:xfrm>
-          <a:prstGeom prst="rect">
-            <a:avLst/>
-          </a:prstGeom>
-          <a:noFill/>
-        </p:spPr>
-        <p:txBody>
-          <a:bodyPr wrap="square">
-            <a:spAutoFit/>
-          </a:bodyPr>
-          <a:lstStyle/>
-          <a:p>
-            <a:pPr>
-              <a:spcAft>
-                <a:spcPts val="600"/>
-              </a:spcAft>
-            </a:pPr>
-            <a:r>
-              <a:rPr sz="1000" b="0">
-                <a:solidFill>
-                  <a:srgbClr val="5B7083"/>
-                </a:solidFill>
-                <a:latin typeface="Helvetica Neue"/>
-                <a:ea typeface="PingFang TC"/>
-              </a:rPr>
-              <a:t>KFB Cloud Coverage</a:t>
-            </a:r>
-          </a:p>
-        </p:txBody>
-      </p:sp>
-      <p:sp>
-        <p:nvSpPr>
-          <p:cNvPr id="8" name="TextBox 7"/>
-          <p:cNvSpPr txBox="1"/>
-          <p:nvPr/>
-        </p:nvSpPr>
-        <p:spPr>
-          <a:xfrm>
-            <a:off x="11155680" y="6446520"/>
-            <a:ext cx="640080" cy="320040"/>
-          </a:xfrm>
-          <a:prstGeom prst="rect">
-            <a:avLst/>
-          </a:prstGeom>
-          <a:noFill/>
-        </p:spPr>
-        <p:txBody>
-          <a:bodyPr wrap="square">
-            <a:spAutoFit/>
-          </a:bodyPr>
-          <a:lstStyle/>
-          <a:p>
-            <a:pPr algn="r">
-              <a:spcAft>
-                <a:spcPts val="600"/>
-              </a:spcAft>
-            </a:pPr>
-            <a:r>
-              <a:rPr sz="1000" b="0">
-                <a:solidFill>
-                  <a:srgbClr val="5B7083"/>
-                </a:solidFill>
-                <a:latin typeface="Helvetica Neue"/>
-                <a:ea typeface="PingFang TC"/>
-              </a:rPr>
-              <a:t>7 / 10</a:t>
-            </a:r>
-          </a:p>
-        </p:txBody>
-      </p:sp>
-    </p:spTree>
-  </p:cSld>
-  <p:clrMapOvr>
-    <a:masterClrMapping/>
-  </p:clrMapOvr>
-</p:sld>
-</file>
-
-<file path=ppt/slides/slide8.xml><?xml version="1.0" encoding="utf-8"?>
-<p:sld xmlns:a="http://schemas.openxmlformats.org/drawingml/2006/main" xmlns:p="http://schemas.openxmlformats.org/presentationml/2006/main" xmlns:r="http://schemas.openxmlformats.org/officeDocument/2006/relationships">
-  <p:cSld>
-    <p:spTree>
-      <p:nvGrpSpPr>
-        <p:cNvPr id="1" name=""/>
-        <p:cNvGrpSpPr/>
-        <p:nvPr/>
-      </p:nvGrpSpPr>
-      <p:grpSpPr/>
-      <p:sp>
-        <p:nvSpPr>
-          <p:cNvPr id="2" name="Rectangle 1"/>
-          <p:cNvSpPr/>
-          <p:nvPr/>
-        </p:nvSpPr>
-        <p:spPr>
-          <a:xfrm>
-            <a:off x="502920" y="384048"/>
-            <a:ext cx="82296" cy="566928"/>
-          </a:xfrm>
-          <a:prstGeom prst="rect">
-            <a:avLst/>
-          </a:prstGeom>
-          <a:solidFill>
-            <a:srgbClr val="2F80B9"/>
-          </a:solidFill>
-          <a:ln>
-            <a:noFill/>
-          </a:ln>
-        </p:spPr>
-        <p:style>
-          <a:lnRef idx="1">
-            <a:schemeClr val="accent1"/>
-          </a:lnRef>
-          <a:fillRef idx="3">
-            <a:schemeClr val="accent1"/>
-          </a:fillRef>
-          <a:effectRef idx="2">
-            <a:schemeClr val="accent1"/>
-          </a:effectRef>
-          <a:fontRef idx="minor">
-            <a:schemeClr val="lt1"/>
-          </a:fontRef>
-        </p:style>
-        <p:txBody>
-          <a:bodyPr rtlCol="0" anchor="ctr"/>
-          <a:lstStyle/>
-          <a:p>
-            <a:pPr algn="ctr"/>
-          </a:p>
-        </p:txBody>
-      </p:sp>
-      <p:sp>
-        <p:nvSpPr>
-          <p:cNvPr id="3" name="TextBox 2"/>
-          <p:cNvSpPr txBox="1"/>
-          <p:nvPr/>
-        </p:nvSpPr>
-        <p:spPr>
-          <a:xfrm>
-            <a:off x="731520" y="274320"/>
-            <a:ext cx="10881360" cy="914400"/>
-          </a:xfrm>
-          <a:prstGeom prst="rect">
-            <a:avLst/>
-          </a:prstGeom>
-          <a:noFill/>
-        </p:spPr>
-        <p:txBody>
-          <a:bodyPr wrap="square">
-            <a:spAutoFit/>
-          </a:bodyPr>
-          <a:lstStyle/>
-          <a:p>
-            <a:pPr>
-              <a:spcAft>
-                <a:spcPts val="200"/>
-              </a:spcAft>
-            </a:pPr>
-            <a:r>
-              <a:rPr sz="2800" b="1">
-                <a:solidFill>
-                  <a:srgbClr val="142A3E"/>
-                </a:solidFill>
-                <a:latin typeface="Helvetica Neue"/>
-                <a:ea typeface="PingFang TC"/>
-              </a:rPr>
-              <a:t>111 visual 2023 photos</a:t>
-            </a:r>
-          </a:p>
-          <a:p>
-            <a:pPr>
-              <a:spcAft>
-                <a:spcPts val="600"/>
-              </a:spcAft>
-            </a:pPr>
-            <a:r>
-              <a:rPr sz="1300" b="0">
-                <a:solidFill>
-                  <a:srgbClr val="5B7083"/>
-                </a:solidFill>
-                <a:latin typeface="Helvetica Neue"/>
-                <a:ea typeface="PingFang TC"/>
-              </a:rPr>
-              <a:t>Used as human overrides in the date split. Still the best 2023 eye-check we have.</a:t>
+              <a:t>Human overrides in the date split. Best 2023 eye-check we have.</a:t>
             </a:r>
           </a:p>
         </p:txBody>
@@ -8301,8 +8433,8 @@
           <p:nvPr/>
         </p:nvGraphicFramePr>
         <p:xfrm>
-          <a:off x="502920" y="4800600"/>
-          <a:ext cx="9692640" cy="1536192"/>
+          <a:off x="502920" y="4754880"/>
+          <a:ext cx="9692640" cy="1664208"/>
         </p:xfrm>
         <a:graphic>
           <a:graphicData uri="http://schemas.openxmlformats.org/drawingml/2006/table">
@@ -8311,14 +8443,14 @@
                 <a:tableStyleId>{5C22544A-7EE6-4342-B048-85BDC9FD1C3A}</a:tableStyleId>
               </a:tblPr>
               <a:tblGrid>
-                <a:gridCol w="2926080"/>
-                <a:gridCol w="1280160"/>
+                <a:gridCol w="3017520"/>
+                <a:gridCol w="1188720"/>
                 <a:gridCol w="1371600"/>
                 <a:gridCol w="1371600"/>
                 <a:gridCol w="1371600"/>
                 <a:gridCol w="1371600"/>
               </a:tblGrid>
-              <a:tr h="256032">
+              <a:tr h="237744">
                 <a:tc>
                   <a:txBody>
                     <a:bodyPr/>
@@ -8464,7 +8596,7 @@
                   </a:tcPr>
                 </a:tc>
               </a:tr>
-              <a:tr h="256032">
+              <a:tr h="237744">
                 <a:tc>
                   <a:txBody>
                     <a:bodyPr/>
@@ -8586,7 +8718,7 @@
                   <a:tcPr/>
                 </a:tc>
               </a:tr>
-              <a:tr h="256032">
+              <a:tr h="237744">
                 <a:tc>
                   <a:txBody>
                     <a:bodyPr/>
@@ -8601,7 +8733,7 @@
                         </a:defRPr>
                       </a:pPr>
                       <a:r>
-                        <a:t>d413d74</a:t>
+                        <a:t>Previous d413d74</a:t>
                       </a:r>
                     </a:p>
                   </a:txBody>
@@ -8732,7 +8864,7 @@
                   </a:tcPr>
                 </a:tc>
               </a:tr>
-              <a:tr h="256032">
+              <a:tr h="237744">
                 <a:tc>
                   <a:txBody>
                     <a:bodyPr/>
@@ -8747,7 +8879,7 @@
                         </a:defRPr>
                       </a:pPr>
                       <a:r>
-                        <a:t>Shipped final</a:t>
+                        <a:t>Combined final</a:t>
                       </a:r>
                     </a:p>
                   </a:txBody>
@@ -8854,7 +8986,7 @@
                   <a:tcPr/>
                 </a:tc>
               </a:tr>
-              <a:tr h="256032">
+              <a:tr h="237744">
                 <a:tc>
                   <a:txBody>
                     <a:bodyPr/>
@@ -8917,7 +9049,7 @@
                         </a:defRPr>
                       </a:pPr>
                       <a:r>
-                        <a:t>0.982</a:t>
+                        <a:t>0.964</a:t>
                       </a:r>
                     </a:p>
                   </a:txBody>
@@ -8941,7 +9073,7 @@
                         </a:defRPr>
                       </a:pPr>
                       <a:r>
-                        <a:t>0.971</a:t>
+                        <a:t>0.943</a:t>
                       </a:r>
                     </a:p>
                   </a:txBody>
@@ -8989,7 +9121,7 @@
                         </a:defRPr>
                       </a:pPr>
                       <a:r>
-                        <a:t>0.985</a:t>
+                        <a:t>0.971</a:t>
                       </a:r>
                     </a:p>
                   </a:txBody>
@@ -9000,7 +9132,7 @@
                   </a:tcPr>
                 </a:tc>
               </a:tr>
-              <a:tr h="256032">
+              <a:tr h="237744">
                 <a:tc>
                   <a:txBody>
                     <a:bodyPr/>
@@ -9055,7 +9187,7 @@
                         </a:defRPr>
                       </a:pPr>
                       <a:r>
-                        <a:t>0.750</a:t>
+                        <a:t>0.768</a:t>
                       </a:r>
                     </a:p>
                   </a:txBody>
@@ -9075,7 +9207,7 @@
                         </a:defRPr>
                       </a:pPr>
                       <a:r>
-                        <a:t>0.639</a:t>
+                        <a:t>0.657</a:t>
                       </a:r>
                     </a:p>
                   </a:txBody>
@@ -9115,17 +9247,556 @@
                         </a:defRPr>
                       </a:pPr>
                       <a:r>
-                        <a:t>0.767</a:t>
+                        <a:t>0.780</a:t>
                       </a:r>
                     </a:p>
                   </a:txBody>
                   <a:tcPr/>
                 </a:tc>
               </a:tr>
+              <a:tr h="237744">
+                <a:tc>
+                  <a:txBody>
+                    <a:bodyPr/>
+                    <a:lstStyle/>
+                    <a:p>
+                      <a:pPr>
+                        <a:defRPr sz="1200" b="0">
+                          <a:solidFill>
+                            <a:srgbClr val="22303C"/>
+                          </a:solidFill>
+                          <a:latin typeface="Helvetica Neue"/>
+                        </a:defRPr>
+                      </a:pPr>
+                      <a:r>
+                        <a:t>Final · 20 test dates</a:t>
+                      </a:r>
+                    </a:p>
+                  </a:txBody>
+                  <a:tcPr>
+                    <a:solidFill>
+                      <a:srgbClr val="F7FAFC"/>
+                    </a:solidFill>
+                  </a:tcPr>
+                </a:tc>
+                <a:tc>
+                  <a:txBody>
+                    <a:bodyPr/>
+                    <a:lstStyle/>
+                    <a:p>
+                      <a:pPr>
+                        <a:defRPr sz="1200" b="0">
+                          <a:solidFill>
+                            <a:srgbClr val="22303C"/>
+                          </a:solidFill>
+                          <a:latin typeface="Helvetica Neue"/>
+                        </a:defRPr>
+                      </a:pPr>
+                      <a:r>
+                        <a:t>20</a:t>
+                      </a:r>
+                    </a:p>
+                  </a:txBody>
+                  <a:tcPr>
+                    <a:solidFill>
+                      <a:srgbClr val="F7FAFC"/>
+                    </a:solidFill>
+                  </a:tcPr>
+                </a:tc>
+                <a:tc>
+                  <a:txBody>
+                    <a:bodyPr/>
+                    <a:lstStyle/>
+                    <a:p>
+                      <a:pPr>
+                        <a:defRPr sz="1200" b="0">
+                          <a:solidFill>
+                            <a:srgbClr val="22303C"/>
+                          </a:solidFill>
+                          <a:latin typeface="Helvetica Neue"/>
+                        </a:defRPr>
+                      </a:pPr>
+                      <a:r>
+                        <a:t>0.750</a:t>
+                      </a:r>
+                    </a:p>
+                  </a:txBody>
+                  <a:tcPr>
+                    <a:solidFill>
+                      <a:srgbClr val="F7FAFC"/>
+                    </a:solidFill>
+                  </a:tcPr>
+                </a:tc>
+                <a:tc>
+                  <a:txBody>
+                    <a:bodyPr/>
+                    <a:lstStyle/>
+                    <a:p>
+                      <a:pPr>
+                        <a:defRPr sz="1200" b="0">
+                          <a:solidFill>
+                            <a:srgbClr val="22303C"/>
+                          </a:solidFill>
+                          <a:latin typeface="Helvetica Neue"/>
+                        </a:defRPr>
+                      </a:pPr>
+                      <a:r>
+                        <a:t>0.688</a:t>
+                      </a:r>
+                    </a:p>
+                  </a:txBody>
+                  <a:tcPr>
+                    <a:solidFill>
+                      <a:srgbClr val="F7FAFC"/>
+                    </a:solidFill>
+                  </a:tcPr>
+                </a:tc>
+                <a:tc>
+                  <a:txBody>
+                    <a:bodyPr/>
+                    <a:lstStyle/>
+                    <a:p>
+                      <a:pPr>
+                        <a:defRPr sz="1200" b="0">
+                          <a:solidFill>
+                            <a:srgbClr val="22303C"/>
+                          </a:solidFill>
+                          <a:latin typeface="Helvetica Neue"/>
+                        </a:defRPr>
+                      </a:pPr>
+                      <a:r>
+                        <a:t>1.000</a:t>
+                      </a:r>
+                    </a:p>
+                  </a:txBody>
+                  <a:tcPr>
+                    <a:solidFill>
+                      <a:srgbClr val="F7FAFC"/>
+                    </a:solidFill>
+                  </a:tcPr>
+                </a:tc>
+                <a:tc>
+                  <a:txBody>
+                    <a:bodyPr/>
+                    <a:lstStyle/>
+                    <a:p>
+                      <a:pPr>
+                        <a:defRPr sz="1200" b="0">
+                          <a:solidFill>
+                            <a:srgbClr val="22303C"/>
+                          </a:solidFill>
+                          <a:latin typeface="Helvetica Neue"/>
+                        </a:defRPr>
+                      </a:pPr>
+                      <a:r>
+                        <a:t>0.815</a:t>
+                      </a:r>
+                    </a:p>
+                  </a:txBody>
+                  <a:tcPr>
+                    <a:solidFill>
+                      <a:srgbClr val="F7FAFC"/>
+                    </a:solidFill>
+                  </a:tcPr>
+                </a:tc>
+              </a:tr>
             </a:tbl>
           </a:graphicData>
         </a:graphic>
       </p:graphicFrame>
+      <p:sp>
+        <p:nvSpPr>
+          <p:cNvPr id="7" name="TextBox 6"/>
+          <p:cNvSpPr txBox="1"/>
+          <p:nvPr/>
+        </p:nvSpPr>
+        <p:spPr>
+          <a:xfrm>
+            <a:off x="502920" y="6446520"/>
+            <a:ext cx="5486400" cy="320040"/>
+          </a:xfrm>
+          <a:prstGeom prst="rect">
+            <a:avLst/>
+          </a:prstGeom>
+          <a:noFill/>
+        </p:spPr>
+        <p:txBody>
+          <a:bodyPr wrap="square">
+            <a:spAutoFit/>
+          </a:bodyPr>
+          <a:lstStyle/>
+          <a:p>
+            <a:pPr>
+              <a:spcAft>
+                <a:spcPts val="600"/>
+              </a:spcAft>
+            </a:pPr>
+            <a:r>
+              <a:rPr sz="1000" b="0">
+                <a:solidFill>
+                  <a:srgbClr val="5B7083"/>
+                </a:solidFill>
+                <a:latin typeface="Helvetica Neue"/>
+                <a:ea typeface="PingFang TC"/>
+              </a:rPr>
+              <a:t>KFB Cloud Coverage</a:t>
+            </a:r>
+          </a:p>
+        </p:txBody>
+      </p:sp>
+      <p:sp>
+        <p:nvSpPr>
+          <p:cNvPr id="8" name="TextBox 7"/>
+          <p:cNvSpPr txBox="1"/>
+          <p:nvPr/>
+        </p:nvSpPr>
+        <p:spPr>
+          <a:xfrm>
+            <a:off x="11155680" y="6446520"/>
+            <a:ext cx="640080" cy="320040"/>
+          </a:xfrm>
+          <a:prstGeom prst="rect">
+            <a:avLst/>
+          </a:prstGeom>
+          <a:noFill/>
+        </p:spPr>
+        <p:txBody>
+          <a:bodyPr wrap="square">
+            <a:spAutoFit/>
+          </a:bodyPr>
+          <a:lstStyle/>
+          <a:p>
+            <a:pPr algn="r">
+              <a:spcAft>
+                <a:spcPts val="600"/>
+              </a:spcAft>
+            </a:pPr>
+            <a:r>
+              <a:rPr sz="1000" b="0">
+                <a:solidFill>
+                  <a:srgbClr val="5B7083"/>
+                </a:solidFill>
+                <a:latin typeface="Helvetica Neue"/>
+                <a:ea typeface="PingFang TC"/>
+              </a:rPr>
+              <a:t>7 / 10</a:t>
+            </a:r>
+          </a:p>
+        </p:txBody>
+      </p:sp>
+    </p:spTree>
+  </p:cSld>
+  <p:clrMapOvr>
+    <a:masterClrMapping/>
+  </p:clrMapOvr>
+</p:sld>
+</file>
+
+<file path=ppt/slides/slide8.xml><?xml version="1.0" encoding="utf-8"?>
+<p:sld xmlns:a="http://schemas.openxmlformats.org/drawingml/2006/main" xmlns:p="http://schemas.openxmlformats.org/presentationml/2006/main" xmlns:r="http://schemas.openxmlformats.org/officeDocument/2006/relationships">
+  <p:cSld>
+    <p:spTree>
+      <p:nvGrpSpPr>
+        <p:cNvPr id="1" name=""/>
+        <p:cNvGrpSpPr/>
+        <p:nvPr/>
+      </p:nvGrpSpPr>
+      <p:grpSpPr/>
+      <p:sp>
+        <p:nvSpPr>
+          <p:cNvPr id="2" name="Rectangle 1"/>
+          <p:cNvSpPr/>
+          <p:nvPr/>
+        </p:nvSpPr>
+        <p:spPr>
+          <a:xfrm>
+            <a:off x="502920" y="384048"/>
+            <a:ext cx="82296" cy="566928"/>
+          </a:xfrm>
+          <a:prstGeom prst="rect">
+            <a:avLst/>
+          </a:prstGeom>
+          <a:solidFill>
+            <a:srgbClr val="2F80B9"/>
+          </a:solidFill>
+          <a:ln>
+            <a:noFill/>
+          </a:ln>
+        </p:spPr>
+        <p:style>
+          <a:lnRef idx="1">
+            <a:schemeClr val="accent1"/>
+          </a:lnRef>
+          <a:fillRef idx="3">
+            <a:schemeClr val="accent1"/>
+          </a:fillRef>
+          <a:effectRef idx="2">
+            <a:schemeClr val="accent1"/>
+          </a:effectRef>
+          <a:fontRef idx="minor">
+            <a:schemeClr val="lt1"/>
+          </a:fontRef>
+        </p:style>
+        <p:txBody>
+          <a:bodyPr rtlCol="0" anchor="ctr"/>
+          <a:lstStyle/>
+          <a:p>
+            <a:pPr algn="ctr"/>
+          </a:p>
+        </p:txBody>
+      </p:sp>
+      <p:sp>
+        <p:nvSpPr>
+          <p:cNvPr id="3" name="TextBox 2"/>
+          <p:cNvSpPr txBox="1"/>
+          <p:nvPr/>
+        </p:nvSpPr>
+        <p:spPr>
+          <a:xfrm>
+            <a:off x="731520" y="274320"/>
+            <a:ext cx="10881360" cy="914400"/>
+          </a:xfrm>
+          <a:prstGeom prst="rect">
+            <a:avLst/>
+          </a:prstGeom>
+          <a:noFill/>
+        </p:spPr>
+        <p:txBody>
+          <a:bodyPr wrap="square">
+            <a:spAutoFit/>
+          </a:bodyPr>
+          <a:lstStyle/>
+          <a:p>
+            <a:pPr>
+              <a:spcAft>
+                <a:spcPts val="200"/>
+              </a:spcAft>
+            </a:pPr>
+            <a:r>
+              <a:rPr sz="2800" b="1">
+                <a:solidFill>
+                  <a:srgbClr val="142A3E"/>
+                </a:solidFill>
+                <a:latin typeface="Helvetica Neue"/>
+                <a:ea typeface="PingFang TC"/>
+              </a:rPr>
+              <a:t>Day is the operational win — night is still the gap</a:t>
+            </a:r>
+          </a:p>
+          <a:p>
+            <a:pPr>
+              <a:spcAft>
+                <a:spcPts val="600"/>
+              </a:spcAft>
+            </a:pPr>
+            <a:r>
+              <a:rPr sz="1300" b="0">
+                <a:solidFill>
+                  <a:srgbClr val="5B7083"/>
+                </a:solidFill>
+                <a:latin typeface="Helvetica Neue"/>
+                <a:ea typeface="PingFang TC"/>
+              </a:rPr>
+              <a:t>111-photo split: 55 day / 56 night.</a:t>
+            </a:r>
+          </a:p>
+        </p:txBody>
+      </p:sp>
+      <p:pic>
+        <p:nvPicPr>
+          <p:cNvPr id="4" name="Picture 3" descr="update_acc.png"/>
+          <p:cNvPicPr>
+            <a:picLocks noChangeAspect="1"/>
+          </p:cNvPicPr>
+          <p:nvPr/>
+        </p:nvPicPr>
+        <p:blipFill>
+          <a:blip r:embed="rId2"/>
+          <a:stretch>
+            <a:fillRect/>
+          </a:stretch>
+        </p:blipFill>
+        <p:spPr>
+          <a:xfrm>
+            <a:off x="365760" y="1371600"/>
+            <a:ext cx="6858000" cy="3248526"/>
+          </a:xfrm>
+          <a:prstGeom prst="rect">
+            <a:avLst/>
+          </a:prstGeom>
+        </p:spPr>
+      </p:pic>
+      <p:sp>
+        <p:nvSpPr>
+          <p:cNvPr id="5" name="Rounded Rectangle 4"/>
+          <p:cNvSpPr/>
+          <p:nvPr/>
+        </p:nvSpPr>
+        <p:spPr>
+          <a:xfrm>
+            <a:off x="7360920" y="1417320"/>
+            <a:ext cx="4343400" cy="4709160"/>
+          </a:xfrm>
+          <a:prstGeom prst="roundRect">
+            <a:avLst>
+              <a:gd name="adj" fmla="val 6000"/>
+            </a:avLst>
+          </a:prstGeom>
+          <a:solidFill>
+            <a:srgbClr val="F2F6F9"/>
+          </a:solidFill>
+          <a:ln>
+            <a:noFill/>
+          </a:ln>
+          <a:effectLst/>
+        </p:spPr>
+        <p:style>
+          <a:lnRef idx="1">
+            <a:schemeClr val="accent1"/>
+          </a:lnRef>
+          <a:fillRef idx="3">
+            <a:schemeClr val="accent1"/>
+          </a:fillRef>
+          <a:effectRef idx="2">
+            <a:schemeClr val="accent1"/>
+          </a:effectRef>
+          <a:fontRef idx="minor">
+            <a:schemeClr val="lt1"/>
+          </a:fontRef>
+        </p:style>
+        <p:txBody>
+          <a:bodyPr rtlCol="0" anchor="ctr"/>
+          <a:lstStyle/>
+          <a:p>
+            <a:pPr algn="ctr"/>
+          </a:p>
+        </p:txBody>
+      </p:sp>
+      <p:sp>
+        <p:nvSpPr>
+          <p:cNvPr id="6" name="TextBox 5"/>
+          <p:cNvSpPr txBox="1"/>
+          <p:nvPr/>
+        </p:nvSpPr>
+        <p:spPr>
+          <a:xfrm>
+            <a:off x="7589520" y="1600200"/>
+            <a:ext cx="3931920" cy="4434840"/>
+          </a:xfrm>
+          <a:prstGeom prst="rect">
+            <a:avLst/>
+          </a:prstGeom>
+          <a:noFill/>
+        </p:spPr>
+        <p:txBody>
+          <a:bodyPr wrap="square">
+            <a:spAutoFit/>
+          </a:bodyPr>
+          <a:lstStyle/>
+          <a:p>
+            <a:pPr>
+              <a:spcAft>
+                <a:spcPts val="800"/>
+              </a:spcAft>
+            </a:pPr>
+            <a:r>
+              <a:rPr sz="1600" b="1">
+                <a:solidFill>
+                  <a:srgbClr val="142A3E"/>
+                </a:solidFill>
+                <a:latin typeface="Helvetica Neue"/>
+                <a:ea typeface="PingFang TC"/>
+              </a:rPr>
+              <a:t>What changed</a:t>
+            </a:r>
+          </a:p>
+          <a:p>
+            <a:pPr>
+              <a:spcAft>
+                <a:spcPts val="700"/>
+              </a:spcAft>
+            </a:pPr>
+            <a:r>
+              <a:rPr sz="1400" b="0">
+                <a:solidFill>
+                  <a:srgbClr val="22303C"/>
+                </a:solidFill>
+                <a:latin typeface="Helvetica Neue"/>
+                <a:ea typeface="PingFang TC"/>
+              </a:rPr>
+              <a:t>•  Day 94.5% → 96.4%.</a:t>
+            </a:r>
+          </a:p>
+          <a:p>
+            <a:pPr>
+              <a:spcAft>
+                <a:spcPts val="700"/>
+              </a:spcAft>
+            </a:pPr>
+            <a:r>
+              <a:rPr sz="1400" b="0">
+                <a:solidFill>
+                  <a:srgbClr val="22303C"/>
+                </a:solidFill>
+                <a:latin typeface="Helvetica Neue"/>
+                <a:ea typeface="PingFang TC"/>
+              </a:rPr>
+              <a:t>•  Night 73.2% → 76.8% (precision 0.66).</a:t>
+            </a:r>
+          </a:p>
+          <a:p>
+            <a:pPr>
+              <a:spcAft>
+                <a:spcPts val="700"/>
+              </a:spcAft>
+            </a:pPr>
+            <a:r>
+              <a:rPr sz="1400" b="0">
+                <a:solidFill>
+                  <a:srgbClr val="22303C"/>
+                </a:solidFill>
+                <a:latin typeface="Helvetica Neue"/>
+                <a:ea typeface="PingFang TC"/>
+              </a:rPr>
+              <a:t>•  111 overall 83.8% → 86.5% vs rules 73.0%.</a:t>
+            </a:r>
+          </a:p>
+          <a:p>
+            <a:pPr>
+              <a:spcAft>
+                <a:spcPts val="1000"/>
+              </a:spcAft>
+            </a:pPr>
+            <a:r>
+              <a:rPr sz="1400" b="0">
+                <a:solidFill>
+                  <a:srgbClr val="22303C"/>
+                </a:solidFill>
+                <a:latin typeface="Helvetica Neue"/>
+                <a:ea typeface="PingFang TC"/>
+              </a:rPr>
+              <a:t>•  20 held-out dates: 75.0% vs d413d74 70.0%.</a:t>
+            </a:r>
+          </a:p>
+          <a:p>
+            <a:pPr>
+              <a:spcAft>
+                <a:spcPts val="600"/>
+              </a:spcAft>
+            </a:pPr>
+            <a:r>
+              <a:rPr sz="1300" b="1">
+                <a:solidFill>
+                  <a:srgbClr val="2F80B9"/>
+                </a:solidFill>
+                <a:latin typeface="Helvetica Neue"/>
+                <a:ea typeface="PingFang TC"/>
+              </a:rPr>
+              <a:t>Night faint-light false alarms remain the process debt.</a:t>
+            </a:r>
+          </a:p>
+        </p:txBody>
+      </p:sp>
       <p:sp>
         <p:nvSpPr>
           <p:cNvPr id="7" name="TextBox 6"/>
@@ -9319,7 +9990,7 @@
                 <a:latin typeface="Helvetica Neue"/>
                 <a:ea typeface="PingFang TC"/>
               </a:rPr>
-              <a:t>The process gain is day recall. The process debt is night precision.</a:t>
+              <a:t>Minutes plus visual overrides lifted day. Night precision is still the debt.</a:t>
             </a:r>
           </a:p>
         </p:txBody>
@@ -9422,7 +10093,7 @@
                 <a:latin typeface="Helvetica Neue"/>
                 <a:ea typeface="PingFang TC"/>
               </a:rPr>
-              <a:t>•  111-photo 83.8% -&gt; 86.5% vs rules 73.0%</a:t>
+              <a:t>•  111-photo 83.8% → 86.5% vs rules 73.0%</a:t>
             </a:r>
           </a:p>
           <a:p>
@@ -9456,7 +10127,7 @@
                 <a:latin typeface="Helvetica Neue"/>
                 <a:ea typeface="PingFang TC"/>
               </a:rPr>
-              <a:t>•  Day 98.2% is briefable as operational</a:t>
+              <a:t>•  Day 96.4% · night 76.8%</a:t>
             </a:r>
           </a:p>
           <a:p>
@@ -9473,7 +10144,7 @@
                 <a:latin typeface="Helvetica Neue"/>
                 <a:ea typeface="PingFang TC"/>
               </a:rPr>
-              <a:t>•  Golden-all 2016 95.1% -&gt; 97.2%</a:t>
+              <a:t>•  Golden-all 2016 95.1% → 96.5%</a:t>
             </a:r>
           </a:p>
         </p:txBody>
@@ -9576,7 +10247,7 @@
                 <a:latin typeface="Helvetica Neue"/>
                 <a:ea typeface="PingFang TC"/>
               </a:rPr>
-              <a:t>•  Night 75.0% (precision 0.64)</a:t>
+              <a:t>•  Night precision still 0.66</a:t>
             </a:r>
           </a:p>
           <a:p>
@@ -9593,7 +10264,7 @@
                 <a:latin typeface="Helvetica Neue"/>
                 <a:ea typeface="PingFang TC"/>
               </a:rPr>
-              <a:t>•  13 of 15 errors on the 111 are night false alarms</a:t>
+              <a:t>•  20 held-out 111 dates: 75% — small n</a:t>
             </a:r>
           </a:p>
           <a:p>
@@ -9610,7 +10281,7 @@
                 <a:latin typeface="Helvetica Neue"/>
                 <a:ea typeface="PingFang TC"/>
               </a:rPr>
-              <a:t>•  166k extra minutes made honest checks worse</a:t>
+              <a:t>•  USB minutes die 22 Apr — no May–Dec 1-minute coverage</a:t>
             </a:r>
           </a:p>
           <a:p>
@@ -9627,7 +10298,7 @@
                 <a:latin typeface="Helvetica Neue"/>
                 <a:ea typeface="PingFang TC"/>
               </a:rPr>
-              <a:t>•  Faint-light / fog / lens-obstruction still confuse both</a:t>
+              <a:t>•  Heuristic seed still dominates most train labels</a:t>
             </a:r>
           </a:p>
         </p:txBody>
@@ -9730,7 +10401,7 @@
                 <a:latin typeface="Helvetica Neue"/>
                 <a:ea typeface="PingFang TC"/>
               </a:rPr>
-              <a:t>1. Re-label night + borderline fog at full resolution.   2. Hold those 111 (and new night labels) fully out of the next fit.   3. Only ship a per-minute model once the extract covers a full year.</a:t>
+              <a:t>1. Hold the 111 fully out of the next fit.   2. Re-label night + borderline fog at full resolution.   3. If another USB year appears, extract it — keep date-balance.</a:t>
             </a:r>
           </a:p>
         </p:txBody>

</xml_diff>